<commit_message>
rapport J+7: intègre feedback V2 (benchmarks, CTA, mentors)
- Page 4: ajout colonne "VS Moyenne" + benchmarks SaaS B2B (CXL 2025),
  graphique tendance visites J1→J7 avec pic J4 (+189%)
- Page 5: ajout CTA partenaires "Aidez-nous à promouvoir The Pulse"
- Page 8: nouveau slide Mentors & Startups assignées
  (Ali El Amrani, Youssef Mamou, Tarik Fadli, Mohammed Damiri)
- PDF et PPTX synchronisés (8 pages/slides)

Co-Authored-By: Claude Opus 4.6 <noreply@anthropic.com>
</commit_message>
<xml_diff>
--- a/Rapport_J7_ThePulse_Partenaires.pptx
+++ b/Rapport_J7_ThePulse_Partenaires.pptx
@@ -12,6 +12,7 @@
     <p:sldId id="260" r:id="rId11"/>
     <p:sldId id="261" r:id="rId12"/>
     <p:sldId id="262" r:id="rId13"/>
+    <p:sldId id="263" r:id="rId14"/>
   </p:sldIdLst>
   <p:sldSz cx="9144000" cy="6858000" type="screen4x3"/>
   <p:notesSz cx="6858000" cy="9144000"/>
@@ -9027,7 +9028,7 @@
         </p:nvGraphicFramePr>
         <p:xfrm>
           <a:off x="365760" y="1005840"/>
-          <a:ext cx="6035040" cy="2194560"/>
+          <a:ext cx="6217920" cy="2194560"/>
         </p:xfrm>
         <a:graphic>
           <a:graphicData uri="http://schemas.openxmlformats.org/drawingml/2006/table">
@@ -9036,9 +9037,10 @@
                 <a:tableStyleId>{5C22544A-7EE6-4342-B048-85BDC9FD1C3A}</a:tableStyleId>
               </a:tblPr>
               <a:tblGrid>
-                <a:gridCol w="2560320"/>
+                <a:gridCol w="2194560"/>
+                <a:gridCol w="731520"/>
+                <a:gridCol w="1005840"/>
                 <a:gridCol w="914400"/>
-                <a:gridCol w="1188720"/>
                 <a:gridCol w="1371600"/>
               </a:tblGrid>
               <a:tr h="274320">
@@ -9124,7 +9126,30 @@
                         </a:defRPr>
                       </a:pPr>
                       <a:r>
-                        <a:t>TAUX DE REBOND</a:t>
+                        <a:t>REBOND</a:t>
+                      </a:r>
+                    </a:p>
+                  </a:txBody>
+                  <a:tcPr>
+                    <a:solidFill>
+                      <a:srgbClr val="0F172A"/>
+                    </a:solidFill>
+                  </a:tcPr>
+                </a:tc>
+                <a:tc>
+                  <a:txBody>
+                    <a:bodyPr/>
+                    <a:lstStyle/>
+                    <a:p>
+                      <a:pPr>
+                        <a:defRPr sz="800" b="1">
+                          <a:solidFill>
+                            <a:srgbClr val="FFFFFF"/>
+                          </a:solidFill>
+                        </a:defRPr>
+                      </a:pPr>
+                      <a:r>
+                        <a:t>VS MOYENNE*</a:t>
                       </a:r>
                     </a:p>
                   </a:txBody>
@@ -9228,6 +9253,29 @@
                     </a:solidFill>
                   </a:tcPr>
                 </a:tc>
+                <a:tc>
+                  <a:txBody>
+                    <a:bodyPr/>
+                    <a:lstStyle/>
+                    <a:p>
+                      <a:pPr>
+                        <a:defRPr sz="800" b="0">
+                          <a:solidFill>
+                            <a:srgbClr val="0F172A"/>
+                          </a:solidFill>
+                        </a:defRPr>
+                      </a:pPr>
+                      <a:r>
+                        <a:t>▲ Page #1</a:t>
+                      </a:r>
+                    </a:p>
+                  </a:txBody>
+                  <a:tcPr>
+                    <a:solidFill>
+                      <a:srgbClr val="F8FAFC"/>
+                    </a:solidFill>
+                  </a:tcPr>
+                </a:tc>
               </a:tr>
               <a:tr h="274320">
                 <a:tc>
@@ -9313,6 +9361,29 @@
                       </a:pPr>
                       <a:r>
                         <a:t>36,5%</a:t>
+                      </a:r>
+                    </a:p>
+                  </a:txBody>
+                  <a:tcPr>
+                    <a:solidFill>
+                      <a:srgbClr val="FFFFFF"/>
+                    </a:solidFill>
+                  </a:tcPr>
+                </a:tc>
+                <a:tc>
+                  <a:txBody>
+                    <a:bodyPr/>
+                    <a:lstStyle/>
+                    <a:p>
+                      <a:pPr>
+                        <a:defRPr sz="800" b="0">
+                          <a:solidFill>
+                            <a:srgbClr val="0F172A"/>
+                          </a:solidFill>
+                        </a:defRPr>
+                      </a:pPr>
+                      <a:r>
+                        <a:t>Rebond moyen</a:t>
                       </a:r>
                     </a:p>
                   </a:txBody>
@@ -9416,6 +9487,29 @@
                     </a:solidFill>
                   </a:tcPr>
                 </a:tc>
+                <a:tc>
+                  <a:txBody>
+                    <a:bodyPr/>
+                    <a:lstStyle/>
+                    <a:p>
+                      <a:pPr>
+                        <a:defRPr sz="800" b="0">
+                          <a:solidFill>
+                            <a:srgbClr val="0F172A"/>
+                          </a:solidFill>
+                        </a:defRPr>
+                      </a:pPr>
+                      <a:r>
+                        <a:t>▲ Fort intérêt</a:t>
+                      </a:r>
+                    </a:p>
+                  </a:txBody>
+                  <a:tcPr>
+                    <a:solidFill>
+                      <a:srgbClr val="F8FAFC"/>
+                    </a:solidFill>
+                  </a:tcPr>
+                </a:tc>
               </a:tr>
               <a:tr h="274320">
                 <a:tc>
@@ -9501,6 +9595,29 @@
                       </a:pPr>
                       <a:r>
                         <a:t>11,5%</a:t>
+                      </a:r>
+                    </a:p>
+                  </a:txBody>
+                  <a:tcPr>
+                    <a:solidFill>
+                      <a:srgbClr val="FFFFFF"/>
+                    </a:solidFill>
+                  </a:tcPr>
+                </a:tc>
+                <a:tc>
+                  <a:txBody>
+                    <a:bodyPr/>
+                    <a:lstStyle/>
+                    <a:p>
+                      <a:pPr>
+                        <a:defRPr sz="800" b="0">
+                          <a:solidFill>
+                            <a:srgbClr val="0F172A"/>
+                          </a:solidFill>
+                        </a:defRPr>
+                      </a:pPr>
+                      <a:r>
+                        <a:t>▲ Très engagé</a:t>
                       </a:r>
                     </a:p>
                   </a:txBody>
@@ -9604,6 +9721,29 @@
                     </a:solidFill>
                   </a:tcPr>
                 </a:tc>
+                <a:tc>
+                  <a:txBody>
+                    <a:bodyPr/>
+                    <a:lstStyle/>
+                    <a:p>
+                      <a:pPr>
+                        <a:defRPr sz="800" b="0">
+                          <a:solidFill>
+                            <a:srgbClr val="0F172A"/>
+                          </a:solidFill>
+                        </a:defRPr>
+                      </a:pPr>
+                      <a:r>
+                        <a:t>▲ Très engagé</a:t>
+                      </a:r>
+                    </a:p>
+                  </a:txBody>
+                  <a:tcPr>
+                    <a:solidFill>
+                      <a:srgbClr val="F8FAFC"/>
+                    </a:solidFill>
+                  </a:tcPr>
+                </a:tc>
               </a:tr>
               <a:tr h="274320">
                 <a:tc>
@@ -9689,6 +9829,29 @@
                       </a:pPr>
                       <a:r>
                         <a:t>14,2%</a:t>
+                      </a:r>
+                    </a:p>
+                  </a:txBody>
+                  <a:tcPr>
+                    <a:solidFill>
+                      <a:srgbClr val="FFFFFF"/>
+                    </a:solidFill>
+                  </a:tcPr>
+                </a:tc>
+                <a:tc>
+                  <a:txBody>
+                    <a:bodyPr/>
+                    <a:lstStyle/>
+                    <a:p>
+                      <a:pPr>
+                        <a:defRPr sz="800" b="0">
+                          <a:solidFill>
+                            <a:srgbClr val="0F172A"/>
+                          </a:solidFill>
+                        </a:defRPr>
+                      </a:pPr>
+                      <a:r>
+                        <a:t>▲ Engagé</a:t>
                       </a:r>
                     </a:p>
                   </a:txBody>
@@ -9792,164 +9955,6 @@
                     </a:solidFill>
                   </a:tcPr>
                 </a:tc>
-              </a:tr>
-            </a:tbl>
-          </a:graphicData>
-        </a:graphic>
-      </p:graphicFrame>
-      <p:sp>
-        <p:nvSpPr>
-          <p:cNvPr id="9" name="TextBox 8"/>
-          <p:cNvSpPr txBox="1"/>
-          <p:nvPr/>
-        </p:nvSpPr>
-        <p:spPr>
-          <a:xfrm>
-            <a:off x="365760" y="3429000"/>
-            <a:ext cx="5486400" cy="274320"/>
-          </a:xfrm>
-          <a:prstGeom prst="rect">
-            <a:avLst/>
-          </a:prstGeom>
-          <a:noFill/>
-        </p:spPr>
-        <p:txBody>
-          <a:bodyPr wrap="square">
-            <a:spAutoFit/>
-          </a:bodyPr>
-          <a:lstStyle/>
-          <a:p>
-            <a:pPr algn="l">
-              <a:defRPr sz="1300" b="1">
-                <a:solidFill>
-                  <a:srgbClr val="0F172A"/>
-                </a:solidFill>
-              </a:defRPr>
-            </a:pPr>
-            <a:r>
-              <a:t>Événements clés (interactions utilisateurs)</a:t>
-            </a:r>
-          </a:p>
-        </p:txBody>
-      </p:sp>
-      <p:graphicFrame>
-        <p:nvGraphicFramePr>
-          <p:cNvPr id="10" name="Table 9"/>
-          <p:cNvGraphicFramePr>
-            <a:graphicFrameLocks noGrp="1"/>
-          </p:cNvGraphicFramePr>
-          <p:nvPr/>
-        </p:nvGraphicFramePr>
-        <p:xfrm>
-          <a:off x="365760" y="3749039"/>
-          <a:ext cx="7772400" cy="2194560"/>
-        </p:xfrm>
-        <a:graphic>
-          <a:graphicData uri="http://schemas.openxmlformats.org/drawingml/2006/table">
-            <a:tbl>
-              <a:tblPr firstRow="1" bandRow="1">
-                <a:tableStyleId>{5C22544A-7EE6-4342-B048-85BDC9FD1C3A}</a:tableStyleId>
-              </a:tblPr>
-              <a:tblGrid>
-                <a:gridCol w="1828800"/>
-                <a:gridCol w="914400"/>
-                <a:gridCol w="5029200"/>
-              </a:tblGrid>
-              <a:tr h="274320">
-                <a:tc>
-                  <a:txBody>
-                    <a:bodyPr/>
-                    <a:lstStyle/>
-                    <a:p>
-                      <a:pPr>
-                        <a:defRPr sz="800" b="1">
-                          <a:solidFill>
-                            <a:srgbClr val="FFFFFF"/>
-                          </a:solidFill>
-                        </a:defRPr>
-                      </a:pPr>
-                      <a:r>
-                        <a:t>ÉVÉNEMENT</a:t>
-                      </a:r>
-                    </a:p>
-                  </a:txBody>
-                  <a:tcPr>
-                    <a:solidFill>
-                      <a:srgbClr val="0F172A"/>
-                    </a:solidFill>
-                  </a:tcPr>
-                </a:tc>
-                <a:tc>
-                  <a:txBody>
-                    <a:bodyPr/>
-                    <a:lstStyle/>
-                    <a:p>
-                      <a:pPr>
-                        <a:defRPr sz="800" b="1">
-                          <a:solidFill>
-                            <a:srgbClr val="FFFFFF"/>
-                          </a:solidFill>
-                        </a:defRPr>
-                      </a:pPr>
-                      <a:r>
-                        <a:t>NOMBRE</a:t>
-                      </a:r>
-                    </a:p>
-                  </a:txBody>
-                  <a:tcPr>
-                    <a:solidFill>
-                      <a:srgbClr val="0F172A"/>
-                    </a:solidFill>
-                  </a:tcPr>
-                </a:tc>
-                <a:tc>
-                  <a:txBody>
-                    <a:bodyPr/>
-                    <a:lstStyle/>
-                    <a:p>
-                      <a:pPr>
-                        <a:defRPr sz="800" b="1">
-                          <a:solidFill>
-                            <a:srgbClr val="FFFFFF"/>
-                          </a:solidFill>
-                        </a:defRPr>
-                      </a:pPr>
-                      <a:r>
-                        <a:t>INTERPRÉTATION</a:t>
-                      </a:r>
-                    </a:p>
-                  </a:txBody>
-                  <a:tcPr>
-                    <a:solidFill>
-                      <a:srgbClr val="0F172A"/>
-                    </a:solidFill>
-                  </a:tcPr>
-                </a:tc>
-              </a:tr>
-              <a:tr h="274320">
-                <a:tc>
-                  <a:txBody>
-                    <a:bodyPr/>
-                    <a:lstStyle/>
-                    <a:p>
-                      <a:pPr>
-                        <a:defRPr sz="800" b="1">
-                          <a:solidFill>
-                            <a:srgbClr val="0F172A"/>
-                          </a:solidFill>
-                        </a:defRPr>
-                      </a:pPr>
-                      <a:r>
-                        <a:t>Pages vues</a:t>
-                      </a:r>
-                    </a:p>
-                  </a:txBody>
-                  <a:tcPr>
-                    <a:solidFill>
-                      <a:srgbClr val="F8FAFC"/>
-                    </a:solidFill>
-                  </a:tcPr>
-                </a:tc>
                 <a:tc>
                   <a:txBody>
                     <a:bodyPr/>
@@ -9963,456 +9968,7 @@
                         </a:defRPr>
                       </a:pPr>
                       <a:r>
-                        <a:t>10 000</a:t>
-                      </a:r>
-                    </a:p>
-                  </a:txBody>
-                  <a:tcPr>
-                    <a:solidFill>
-                      <a:srgbClr val="F8FAFC"/>
-                    </a:solidFill>
-                  </a:tcPr>
-                </a:tc>
-                <a:tc>
-                  <a:txBody>
-                    <a:bodyPr/>
-                    <a:lstStyle/>
-                    <a:p>
-                      <a:pPr>
-                        <a:defRPr sz="800" b="0">
-                          <a:solidFill>
-                            <a:srgbClr val="0F172A"/>
-                          </a:solidFill>
-                        </a:defRPr>
-                      </a:pPr>
-                      <a:r>
-                        <a:t>Navigation active sur la plateforme</a:t>
-                      </a:r>
-                    </a:p>
-                  </a:txBody>
-                  <a:tcPr>
-                    <a:solidFill>
-                      <a:srgbClr val="F8FAFC"/>
-                    </a:solidFill>
-                  </a:tcPr>
-                </a:tc>
-              </a:tr>
-              <a:tr h="274320">
-                <a:tc>
-                  <a:txBody>
-                    <a:bodyPr/>
-                    <a:lstStyle/>
-                    <a:p>
-                      <a:pPr>
-                        <a:defRPr sz="800" b="1">
-                          <a:solidFill>
-                            <a:srgbClr val="0F172A"/>
-                          </a:solidFill>
-                        </a:defRPr>
-                      </a:pPr>
-                      <a:r>
-                        <a:t>Engagement utilisateur</a:t>
-                      </a:r>
-                    </a:p>
-                  </a:txBody>
-                  <a:tcPr>
-                    <a:solidFill>
-                      <a:srgbClr val="FFFFFF"/>
-                    </a:solidFill>
-                  </a:tcPr>
-                </a:tc>
-                <a:tc>
-                  <a:txBody>
-                    <a:bodyPr/>
-                    <a:lstStyle/>
-                    <a:p>
-                      <a:pPr>
-                        <a:defRPr sz="800" b="0">
-                          <a:solidFill>
-                            <a:srgbClr val="0F172A"/>
-                          </a:solidFill>
-                        </a:defRPr>
-                      </a:pPr>
-                      <a:r>
-                        <a:t>8 000</a:t>
-                      </a:r>
-                    </a:p>
-                  </a:txBody>
-                  <a:tcPr>
-                    <a:solidFill>
-                      <a:srgbClr val="FFFFFF"/>
-                    </a:solidFill>
-                  </a:tcPr>
-                </a:tc>
-                <a:tc>
-                  <a:txBody>
-                    <a:bodyPr/>
-                    <a:lstStyle/>
-                    <a:p>
-                      <a:pPr>
-                        <a:defRPr sz="800" b="0">
-                          <a:solidFill>
-                            <a:srgbClr val="0F172A"/>
-                          </a:solidFill>
-                        </a:defRPr>
-                      </a:pPr>
-                      <a:r>
-                        <a:t>Interactions significatives</a:t>
-                      </a:r>
-                    </a:p>
-                  </a:txBody>
-                  <a:tcPr>
-                    <a:solidFill>
-                      <a:srgbClr val="FFFFFF"/>
-                    </a:solidFill>
-                  </a:tcPr>
-                </a:tc>
-              </a:tr>
-              <a:tr h="274320">
-                <a:tc>
-                  <a:txBody>
-                    <a:bodyPr/>
-                    <a:lstStyle/>
-                    <a:p>
-                      <a:pPr>
-                        <a:defRPr sz="800" b="1">
-                          <a:solidFill>
-                            <a:srgbClr val="0F172A"/>
-                          </a:solidFill>
-                        </a:defRPr>
-                      </a:pPr>
-                      <a:r>
-                        <a:t>Scroll</a:t>
-                      </a:r>
-                    </a:p>
-                  </a:txBody>
-                  <a:tcPr>
-                    <a:solidFill>
-                      <a:srgbClr val="F8FAFC"/>
-                    </a:solidFill>
-                  </a:tcPr>
-                </a:tc>
-                <a:tc>
-                  <a:txBody>
-                    <a:bodyPr/>
-                    <a:lstStyle/>
-                    <a:p>
-                      <a:pPr>
-                        <a:defRPr sz="800" b="0">
-                          <a:solidFill>
-                            <a:srgbClr val="0F172A"/>
-                          </a:solidFill>
-                        </a:defRPr>
-                      </a:pPr>
-                      <a:r>
-                        <a:t>3 400</a:t>
-                      </a:r>
-                    </a:p>
-                  </a:txBody>
-                  <a:tcPr>
-                    <a:solidFill>
-                      <a:srgbClr val="F8FAFC"/>
-                    </a:solidFill>
-                  </a:tcPr>
-                </a:tc>
-                <a:tc>
-                  <a:txBody>
-                    <a:bodyPr/>
-                    <a:lstStyle/>
-                    <a:p>
-                      <a:pPr>
-                        <a:defRPr sz="800" b="0">
-                          <a:solidFill>
-                            <a:srgbClr val="0F172A"/>
-                          </a:solidFill>
-                        </a:defRPr>
-                      </a:pPr>
-                      <a:r>
-                        <a:t>Consultation approfondie du contenu</a:t>
-                      </a:r>
-                    </a:p>
-                  </a:txBody>
-                  <a:tcPr>
-                    <a:solidFill>
-                      <a:srgbClr val="F8FAFC"/>
-                    </a:solidFill>
-                  </a:tcPr>
-                </a:tc>
-              </a:tr>
-              <a:tr h="274320">
-                <a:tc>
-                  <a:txBody>
-                    <a:bodyPr/>
-                    <a:lstStyle/>
-                    <a:p>
-                      <a:pPr>
-                        <a:defRPr sz="800" b="1">
-                          <a:solidFill>
-                            <a:srgbClr val="0F172A"/>
-                          </a:solidFill>
-                        </a:defRPr>
-                      </a:pPr>
-                      <a:r>
-                        <a:t>Début de session</a:t>
-                      </a:r>
-                    </a:p>
-                  </a:txBody>
-                  <a:tcPr>
-                    <a:solidFill>
-                      <a:srgbClr val="FFFFFF"/>
-                    </a:solidFill>
-                  </a:tcPr>
-                </a:tc>
-                <a:tc>
-                  <a:txBody>
-                    <a:bodyPr/>
-                    <a:lstStyle/>
-                    <a:p>
-                      <a:pPr>
-                        <a:defRPr sz="800" b="0">
-                          <a:solidFill>
-                            <a:srgbClr val="0F172A"/>
-                          </a:solidFill>
-                        </a:defRPr>
-                      </a:pPr>
-                      <a:r>
-                        <a:t>2 400</a:t>
-                      </a:r>
-                    </a:p>
-                  </a:txBody>
-                  <a:tcPr>
-                    <a:solidFill>
-                      <a:srgbClr val="FFFFFF"/>
-                    </a:solidFill>
-                  </a:tcPr>
-                </a:tc>
-                <a:tc>
-                  <a:txBody>
-                    <a:bodyPr/>
-                    <a:lstStyle/>
-                    <a:p>
-                      <a:pPr>
-                        <a:defRPr sz="800" b="0">
-                          <a:solidFill>
-                            <a:srgbClr val="0F172A"/>
-                          </a:solidFill>
-                        </a:defRPr>
-                      </a:pPr>
-                      <a:r>
-                        <a:t>Visites uniques</a:t>
-                      </a:r>
-                    </a:p>
-                  </a:txBody>
-                  <a:tcPr>
-                    <a:solidFill>
-                      <a:srgbClr val="FFFFFF"/>
-                    </a:solidFill>
-                  </a:tcPr>
-                </a:tc>
-              </a:tr>
-              <a:tr h="274320">
-                <a:tc>
-                  <a:txBody>
-                    <a:bodyPr/>
-                    <a:lstStyle/>
-                    <a:p>
-                      <a:pPr>
-                        <a:defRPr sz="800" b="1">
-                          <a:solidFill>
-                            <a:srgbClr val="0F172A"/>
-                          </a:solidFill>
-                        </a:defRPr>
-                      </a:pPr>
-                      <a:r>
-                        <a:t>Première visite</a:t>
-                      </a:r>
-                    </a:p>
-                  </a:txBody>
-                  <a:tcPr>
-                    <a:solidFill>
-                      <a:srgbClr val="F8FAFC"/>
-                    </a:solidFill>
-                  </a:tcPr>
-                </a:tc>
-                <a:tc>
-                  <a:txBody>
-                    <a:bodyPr/>
-                    <a:lstStyle/>
-                    <a:p>
-                      <a:pPr>
-                        <a:defRPr sz="800" b="0">
-                          <a:solidFill>
-                            <a:srgbClr val="0F172A"/>
-                          </a:solidFill>
-                        </a:defRPr>
-                      </a:pPr>
-                      <a:r>
-                        <a:t>1 600</a:t>
-                      </a:r>
-                    </a:p>
-                  </a:txBody>
-                  <a:tcPr>
-                    <a:solidFill>
-                      <a:srgbClr val="F8FAFC"/>
-                    </a:solidFill>
-                  </a:tcPr>
-                </a:tc>
-                <a:tc>
-                  <a:txBody>
-                    <a:bodyPr/>
-                    <a:lstStyle/>
-                    <a:p>
-                      <a:pPr>
-                        <a:defRPr sz="800" b="0">
-                          <a:solidFill>
-                            <a:srgbClr val="0F172A"/>
-                          </a:solidFill>
-                        </a:defRPr>
-                      </a:pPr>
-                      <a:r>
-                        <a:t>Nouveaux visiteurs</a:t>
-                      </a:r>
-                    </a:p>
-                  </a:txBody>
-                  <a:tcPr>
-                    <a:solidFill>
-                      <a:srgbClr val="F8FAFC"/>
-                    </a:solidFill>
-                  </a:tcPr>
-                </a:tc>
-              </a:tr>
-              <a:tr h="274320">
-                <a:tc>
-                  <a:txBody>
-                    <a:bodyPr/>
-                    <a:lstStyle/>
-                    <a:p>
-                      <a:pPr>
-                        <a:defRPr sz="800" b="1">
-                          <a:solidFill>
-                            <a:srgbClr val="0F172A"/>
-                          </a:solidFill>
-                        </a:defRPr>
-                      </a:pPr>
-                      <a:r>
-                        <a:t>Clics externes (sites startups)</a:t>
-                      </a:r>
-                    </a:p>
-                  </a:txBody>
-                  <a:tcPr>
-                    <a:solidFill>
-                      <a:srgbClr val="FFFFFF"/>
-                    </a:solidFill>
-                  </a:tcPr>
-                </a:tc>
-                <a:tc>
-                  <a:txBody>
-                    <a:bodyPr/>
-                    <a:lstStyle/>
-                    <a:p>
-                      <a:pPr>
-                        <a:defRPr sz="800" b="0">
-                          <a:solidFill>
-                            <a:srgbClr val="0F172A"/>
-                          </a:solidFill>
-                        </a:defRPr>
-                      </a:pPr>
-                      <a:r>
-                        <a:t>450</a:t>
-                      </a:r>
-                    </a:p>
-                  </a:txBody>
-                  <a:tcPr>
-                    <a:solidFill>
-                      <a:srgbClr val="FFFFFF"/>
-                    </a:solidFill>
-                  </a:tcPr>
-                </a:tc>
-                <a:tc>
-                  <a:txBody>
-                    <a:bodyPr/>
-                    <a:lstStyle/>
-                    <a:p>
-                      <a:pPr>
-                        <a:defRPr sz="800" b="0">
-                          <a:solidFill>
-                            <a:srgbClr val="0F172A"/>
-                          </a:solidFill>
-                        </a:defRPr>
-                      </a:pPr>
-                      <a:r>
-                        <a:t>Redirections vers sites des startups référencées</a:t>
-                      </a:r>
-                    </a:p>
-                  </a:txBody>
-                  <a:tcPr>
-                    <a:solidFill>
-                      <a:srgbClr val="FFFFFF"/>
-                    </a:solidFill>
-                  </a:tcPr>
-                </a:tc>
-              </a:tr>
-              <a:tr h="274320">
-                <a:tc>
-                  <a:txBody>
-                    <a:bodyPr/>
-                    <a:lstStyle/>
-                    <a:p>
-                      <a:pPr>
-                        <a:defRPr sz="800" b="1">
-                          <a:solidFill>
-                            <a:srgbClr val="0F172A"/>
-                          </a:solidFill>
-                        </a:defRPr>
-                      </a:pPr>
-                      <a:r>
-                        <a:t>Recherches internes</a:t>
-                      </a:r>
-                    </a:p>
-                  </a:txBody>
-                  <a:tcPr>
-                    <a:solidFill>
-                      <a:srgbClr val="F8FAFC"/>
-                    </a:solidFill>
-                  </a:tcPr>
-                </a:tc>
-                <a:tc>
-                  <a:txBody>
-                    <a:bodyPr/>
-                    <a:lstStyle/>
-                    <a:p>
-                      <a:pPr>
-                        <a:defRPr sz="800" b="0">
-                          <a:solidFill>
-                            <a:srgbClr val="0F172A"/>
-                          </a:solidFill>
-                        </a:defRPr>
-                      </a:pPr>
-                      <a:r>
-                        <a:t>320</a:t>
-                      </a:r>
-                    </a:p>
-                  </a:txBody>
-                  <a:tcPr>
-                    <a:solidFill>
-                      <a:srgbClr val="F8FAFC"/>
-                    </a:solidFill>
-                  </a:tcPr>
-                </a:tc>
-                <a:tc>
-                  <a:txBody>
-                    <a:bodyPr/>
-                    <a:lstStyle/>
-                    <a:p>
-                      <a:pPr>
-                        <a:defRPr sz="800" b="0">
-                          <a:solidFill>
-                            <a:srgbClr val="0F172A"/>
-                          </a:solidFill>
-                        </a:defRPr>
-                      </a:pPr>
-                      <a:r>
-                        <a:t>Filtres par secteur, ville, stade</a:t>
+                        <a:t>▲▲ Excellent</a:t>
                       </a:r>
                     </a:p>
                   </a:txBody>
@@ -10429,14 +9985,924 @@
       </p:graphicFrame>
       <p:sp>
         <p:nvSpPr>
-          <p:cNvPr id="11" name="Rounded Rectangle 10"/>
+          <p:cNvPr id="9" name="TextBox 8"/>
+          <p:cNvSpPr txBox="1"/>
+          <p:nvPr/>
+        </p:nvSpPr>
+        <p:spPr>
+          <a:xfrm>
+            <a:off x="365760" y="3246120"/>
+            <a:ext cx="8229600" cy="182880"/>
+          </a:xfrm>
+          <a:prstGeom prst="rect">
+            <a:avLst/>
+          </a:prstGeom>
+          <a:noFill/>
+        </p:spPr>
+        <p:txBody>
+          <a:bodyPr wrap="square">
+            <a:spAutoFit/>
+          </a:bodyPr>
+          <a:lstStyle/>
+          <a:p>
+            <a:pPr algn="l">
+              <a:defRPr sz="700" b="0">
+                <a:solidFill>
+                  <a:srgbClr val="64748B"/>
+                </a:solidFill>
+              </a:defRPr>
+            </a:pPr>
+            <a:r>
+              <a:t>* Moyenne taux de rebond SaaS B2B : 40-60% (source : CXL / Contentsquare 2025). The Pulse est largement en dessous.</a:t>
+            </a:r>
+          </a:p>
+        </p:txBody>
+      </p:sp>
+      <p:sp>
+        <p:nvSpPr>
+          <p:cNvPr id="10" name="TextBox 9"/>
+          <p:cNvSpPr txBox="1"/>
+          <p:nvPr/>
+        </p:nvSpPr>
+        <p:spPr>
+          <a:xfrm>
+            <a:off x="365760" y="3520440"/>
+            <a:ext cx="5486400" cy="274320"/>
+          </a:xfrm>
+          <a:prstGeom prst="rect">
+            <a:avLst/>
+          </a:prstGeom>
+          <a:noFill/>
+        </p:spPr>
+        <p:txBody>
+          <a:bodyPr wrap="square">
+            <a:spAutoFit/>
+          </a:bodyPr>
+          <a:lstStyle/>
+          <a:p>
+            <a:pPr algn="l">
+              <a:defRPr sz="1300" b="1">
+                <a:solidFill>
+                  <a:srgbClr val="0F172A"/>
+                </a:solidFill>
+              </a:defRPr>
+            </a:pPr>
+            <a:r>
+              <a:t>Tendance des visites (J1 → J7)</a:t>
+            </a:r>
+          </a:p>
+        </p:txBody>
+      </p:sp>
+      <p:sp>
+        <p:nvSpPr>
+          <p:cNvPr id="11" name="TextBox 10"/>
+          <p:cNvSpPr txBox="1"/>
+          <p:nvPr/>
+        </p:nvSpPr>
+        <p:spPr>
+          <a:xfrm>
+            <a:off x="457200" y="3840480"/>
+            <a:ext cx="1188720" cy="228600"/>
+          </a:xfrm>
+          <a:prstGeom prst="rect">
+            <a:avLst/>
+          </a:prstGeom>
+          <a:noFill/>
+        </p:spPr>
+        <p:txBody>
+          <a:bodyPr wrap="square">
+            <a:spAutoFit/>
+          </a:bodyPr>
+          <a:lstStyle/>
+          <a:p>
+            <a:pPr algn="l">
+              <a:defRPr sz="800" b="0">
+                <a:solidFill>
+                  <a:srgbClr val="0F172A"/>
+                </a:solidFill>
+              </a:defRPr>
+            </a:pPr>
+            <a:r>
+              <a:t>J1 (6 avr)</a:t>
+            </a:r>
+          </a:p>
+        </p:txBody>
+      </p:sp>
+      <p:sp>
+        <p:nvSpPr>
+          <p:cNvPr id="12" name="Rounded Rectangle 11"/>
           <p:cNvSpPr/>
           <p:nvPr/>
         </p:nvSpPr>
         <p:spPr>
           <a:xfrm>
-            <a:off x="365760" y="6126480"/>
-            <a:ext cx="8412480" cy="594360"/>
+            <a:off x="1691640" y="3858768"/>
+            <a:ext cx="1582615" cy="182880"/>
+          </a:xfrm>
+          <a:prstGeom prst="roundRect">
+            <a:avLst>
+              <a:gd name="adj" fmla="val 15000"/>
+            </a:avLst>
+          </a:prstGeom>
+          <a:solidFill>
+            <a:srgbClr val="64748B"/>
+          </a:solidFill>
+          <a:ln>
+            <a:noFill/>
+          </a:ln>
+        </p:spPr>
+        <p:style>
+          <a:lnRef idx="1">
+            <a:schemeClr val="accent1"/>
+          </a:lnRef>
+          <a:fillRef idx="3">
+            <a:schemeClr val="accent1"/>
+          </a:fillRef>
+          <a:effectRef idx="2">
+            <a:schemeClr val="accent1"/>
+          </a:effectRef>
+          <a:fontRef idx="minor">
+            <a:schemeClr val="lt1"/>
+          </a:fontRef>
+        </p:style>
+        <p:txBody>
+          <a:bodyPr rtlCol="0" anchor="ctr"/>
+          <a:lstStyle/>
+          <a:p>
+            <a:pPr algn="ctr"/>
+          </a:p>
+        </p:txBody>
+      </p:sp>
+      <p:sp>
+        <p:nvSpPr>
+          <p:cNvPr id="13" name="TextBox 12"/>
+          <p:cNvSpPr txBox="1"/>
+          <p:nvPr/>
+        </p:nvSpPr>
+        <p:spPr>
+          <a:xfrm>
+            <a:off x="3365695" y="3840480"/>
+            <a:ext cx="731520" cy="228600"/>
+          </a:xfrm>
+          <a:prstGeom prst="rect">
+            <a:avLst/>
+          </a:prstGeom>
+          <a:noFill/>
+        </p:spPr>
+        <p:txBody>
+          <a:bodyPr wrap="square">
+            <a:spAutoFit/>
+          </a:bodyPr>
+          <a:lstStyle/>
+          <a:p>
+            <a:pPr algn="l">
+              <a:defRPr sz="700" b="1">
+                <a:solidFill>
+                  <a:srgbClr val="0F172A"/>
+                </a:solidFill>
+              </a:defRPr>
+            </a:pPr>
+            <a:r>
+              <a:t>180 sess.</a:t>
+            </a:r>
+          </a:p>
+        </p:txBody>
+      </p:sp>
+      <p:sp>
+        <p:nvSpPr>
+          <p:cNvPr id="14" name="TextBox 13"/>
+          <p:cNvSpPr txBox="1"/>
+          <p:nvPr/>
+        </p:nvSpPr>
+        <p:spPr>
+          <a:xfrm>
+            <a:off x="457200" y="4133088"/>
+            <a:ext cx="1188720" cy="228600"/>
+          </a:xfrm>
+          <a:prstGeom prst="rect">
+            <a:avLst/>
+          </a:prstGeom>
+          <a:noFill/>
+        </p:spPr>
+        <p:txBody>
+          <a:bodyPr wrap="square">
+            <a:spAutoFit/>
+          </a:bodyPr>
+          <a:lstStyle/>
+          <a:p>
+            <a:pPr algn="l">
+              <a:defRPr sz="800" b="0">
+                <a:solidFill>
+                  <a:srgbClr val="0F172A"/>
+                </a:solidFill>
+              </a:defRPr>
+            </a:pPr>
+            <a:r>
+              <a:t>J2 (7 avr)</a:t>
+            </a:r>
+          </a:p>
+        </p:txBody>
+      </p:sp>
+      <p:sp>
+        <p:nvSpPr>
+          <p:cNvPr id="15" name="Rounded Rectangle 14"/>
+          <p:cNvSpPr/>
+          <p:nvPr/>
+        </p:nvSpPr>
+        <p:spPr>
+          <a:xfrm>
+            <a:off x="1691640" y="4151376"/>
+            <a:ext cx="1934307" cy="182880"/>
+          </a:xfrm>
+          <a:prstGeom prst="roundRect">
+            <a:avLst>
+              <a:gd name="adj" fmla="val 15000"/>
+            </a:avLst>
+          </a:prstGeom>
+          <a:solidFill>
+            <a:srgbClr val="64748B"/>
+          </a:solidFill>
+          <a:ln>
+            <a:noFill/>
+          </a:ln>
+        </p:spPr>
+        <p:style>
+          <a:lnRef idx="1">
+            <a:schemeClr val="accent1"/>
+          </a:lnRef>
+          <a:fillRef idx="3">
+            <a:schemeClr val="accent1"/>
+          </a:fillRef>
+          <a:effectRef idx="2">
+            <a:schemeClr val="accent1"/>
+          </a:effectRef>
+          <a:fontRef idx="minor">
+            <a:schemeClr val="lt1"/>
+          </a:fontRef>
+        </p:style>
+        <p:txBody>
+          <a:bodyPr rtlCol="0" anchor="ctr"/>
+          <a:lstStyle/>
+          <a:p>
+            <a:pPr algn="ctr"/>
+          </a:p>
+        </p:txBody>
+      </p:sp>
+      <p:sp>
+        <p:nvSpPr>
+          <p:cNvPr id="16" name="TextBox 15"/>
+          <p:cNvSpPr txBox="1"/>
+          <p:nvPr/>
+        </p:nvSpPr>
+        <p:spPr>
+          <a:xfrm>
+            <a:off x="3717387" y="4133088"/>
+            <a:ext cx="731520" cy="228600"/>
+          </a:xfrm>
+          <a:prstGeom prst="rect">
+            <a:avLst/>
+          </a:prstGeom>
+          <a:noFill/>
+        </p:spPr>
+        <p:txBody>
+          <a:bodyPr wrap="square">
+            <a:spAutoFit/>
+          </a:bodyPr>
+          <a:lstStyle/>
+          <a:p>
+            <a:pPr algn="l">
+              <a:defRPr sz="700" b="1">
+                <a:solidFill>
+                  <a:srgbClr val="0F172A"/>
+                </a:solidFill>
+              </a:defRPr>
+            </a:pPr>
+            <a:r>
+              <a:t>220 sess.</a:t>
+            </a:r>
+          </a:p>
+        </p:txBody>
+      </p:sp>
+      <p:sp>
+        <p:nvSpPr>
+          <p:cNvPr id="17" name="TextBox 16"/>
+          <p:cNvSpPr txBox="1"/>
+          <p:nvPr/>
+        </p:nvSpPr>
+        <p:spPr>
+          <a:xfrm>
+            <a:off x="457200" y="4425696"/>
+            <a:ext cx="1188720" cy="228600"/>
+          </a:xfrm>
+          <a:prstGeom prst="rect">
+            <a:avLst/>
+          </a:prstGeom>
+          <a:noFill/>
+        </p:spPr>
+        <p:txBody>
+          <a:bodyPr wrap="square">
+            <a:spAutoFit/>
+          </a:bodyPr>
+          <a:lstStyle/>
+          <a:p>
+            <a:pPr algn="l">
+              <a:defRPr sz="800" b="0">
+                <a:solidFill>
+                  <a:srgbClr val="0F172A"/>
+                </a:solidFill>
+              </a:defRPr>
+            </a:pPr>
+            <a:r>
+              <a:t>J3 (8 avr)</a:t>
+            </a:r>
+          </a:p>
+        </p:txBody>
+      </p:sp>
+      <p:sp>
+        <p:nvSpPr>
+          <p:cNvPr id="18" name="Rounded Rectangle 17"/>
+          <p:cNvSpPr/>
+          <p:nvPr/>
+        </p:nvSpPr>
+        <p:spPr>
+          <a:xfrm>
+            <a:off x="1691640" y="4443984"/>
+            <a:ext cx="2549769" cy="182880"/>
+          </a:xfrm>
+          <a:prstGeom prst="roundRect">
+            <a:avLst>
+              <a:gd name="adj" fmla="val 15000"/>
+            </a:avLst>
+          </a:prstGeom>
+          <a:solidFill>
+            <a:srgbClr val="3B82F6"/>
+          </a:solidFill>
+          <a:ln>
+            <a:noFill/>
+          </a:ln>
+        </p:spPr>
+        <p:style>
+          <a:lnRef idx="1">
+            <a:schemeClr val="accent1"/>
+          </a:lnRef>
+          <a:fillRef idx="3">
+            <a:schemeClr val="accent1"/>
+          </a:fillRef>
+          <a:effectRef idx="2">
+            <a:schemeClr val="accent1"/>
+          </a:effectRef>
+          <a:fontRef idx="minor">
+            <a:schemeClr val="lt1"/>
+          </a:fontRef>
+        </p:style>
+        <p:txBody>
+          <a:bodyPr rtlCol="0" anchor="ctr"/>
+          <a:lstStyle/>
+          <a:p>
+            <a:pPr algn="ctr"/>
+          </a:p>
+        </p:txBody>
+      </p:sp>
+      <p:sp>
+        <p:nvSpPr>
+          <p:cNvPr id="19" name="TextBox 18"/>
+          <p:cNvSpPr txBox="1"/>
+          <p:nvPr/>
+        </p:nvSpPr>
+        <p:spPr>
+          <a:xfrm>
+            <a:off x="4332849" y="4425696"/>
+            <a:ext cx="731520" cy="228600"/>
+          </a:xfrm>
+          <a:prstGeom prst="rect">
+            <a:avLst/>
+          </a:prstGeom>
+          <a:noFill/>
+        </p:spPr>
+        <p:txBody>
+          <a:bodyPr wrap="square">
+            <a:spAutoFit/>
+          </a:bodyPr>
+          <a:lstStyle/>
+          <a:p>
+            <a:pPr algn="l">
+              <a:defRPr sz="700" b="1">
+                <a:solidFill>
+                  <a:srgbClr val="0F172A"/>
+                </a:solidFill>
+              </a:defRPr>
+            </a:pPr>
+            <a:r>
+              <a:t>290 sess.</a:t>
+            </a:r>
+          </a:p>
+        </p:txBody>
+      </p:sp>
+      <p:sp>
+        <p:nvSpPr>
+          <p:cNvPr id="20" name="TextBox 19"/>
+          <p:cNvSpPr txBox="1"/>
+          <p:nvPr/>
+        </p:nvSpPr>
+        <p:spPr>
+          <a:xfrm>
+            <a:off x="457200" y="4718304"/>
+            <a:ext cx="1188720" cy="228600"/>
+          </a:xfrm>
+          <a:prstGeom prst="rect">
+            <a:avLst/>
+          </a:prstGeom>
+          <a:noFill/>
+        </p:spPr>
+        <p:txBody>
+          <a:bodyPr wrap="square">
+            <a:spAutoFit/>
+          </a:bodyPr>
+          <a:lstStyle/>
+          <a:p>
+            <a:pPr algn="l">
+              <a:defRPr sz="800" b="0">
+                <a:solidFill>
+                  <a:srgbClr val="0F172A"/>
+                </a:solidFill>
+              </a:defRPr>
+            </a:pPr>
+            <a:r>
+              <a:t>J4 (9 avr)</a:t>
+            </a:r>
+          </a:p>
+        </p:txBody>
+      </p:sp>
+      <p:sp>
+        <p:nvSpPr>
+          <p:cNvPr id="21" name="Rounded Rectangle 20"/>
+          <p:cNvSpPr/>
+          <p:nvPr/>
+        </p:nvSpPr>
+        <p:spPr>
+          <a:xfrm>
+            <a:off x="1691640" y="4736592"/>
+            <a:ext cx="4572000" cy="182880"/>
+          </a:xfrm>
+          <a:prstGeom prst="roundRect">
+            <a:avLst>
+              <a:gd name="adj" fmla="val 15000"/>
+            </a:avLst>
+          </a:prstGeom>
+          <a:solidFill>
+            <a:srgbClr val="00D4AA"/>
+          </a:solidFill>
+          <a:ln>
+            <a:noFill/>
+          </a:ln>
+        </p:spPr>
+        <p:style>
+          <a:lnRef idx="1">
+            <a:schemeClr val="accent1"/>
+          </a:lnRef>
+          <a:fillRef idx="3">
+            <a:schemeClr val="accent1"/>
+          </a:fillRef>
+          <a:effectRef idx="2">
+            <a:schemeClr val="accent1"/>
+          </a:effectRef>
+          <a:fontRef idx="minor">
+            <a:schemeClr val="lt1"/>
+          </a:fontRef>
+        </p:style>
+        <p:txBody>
+          <a:bodyPr rtlCol="0" anchor="ctr"/>
+          <a:lstStyle/>
+          <a:p>
+            <a:pPr algn="ctr"/>
+          </a:p>
+        </p:txBody>
+      </p:sp>
+      <p:sp>
+        <p:nvSpPr>
+          <p:cNvPr id="22" name="TextBox 21"/>
+          <p:cNvSpPr txBox="1"/>
+          <p:nvPr/>
+        </p:nvSpPr>
+        <p:spPr>
+          <a:xfrm>
+            <a:off x="6355080" y="4718304"/>
+            <a:ext cx="731520" cy="228600"/>
+          </a:xfrm>
+          <a:prstGeom prst="rect">
+            <a:avLst/>
+          </a:prstGeom>
+          <a:noFill/>
+        </p:spPr>
+        <p:txBody>
+          <a:bodyPr wrap="square">
+            <a:spAutoFit/>
+          </a:bodyPr>
+          <a:lstStyle/>
+          <a:p>
+            <a:pPr algn="l">
+              <a:defRPr sz="700" b="1">
+                <a:solidFill>
+                  <a:srgbClr val="0F172A"/>
+                </a:solidFill>
+              </a:defRPr>
+            </a:pPr>
+            <a:r>
+              <a:t>520 sess.</a:t>
+            </a:r>
+          </a:p>
+        </p:txBody>
+      </p:sp>
+      <p:sp>
+        <p:nvSpPr>
+          <p:cNvPr id="23" name="TextBox 22"/>
+          <p:cNvSpPr txBox="1"/>
+          <p:nvPr/>
+        </p:nvSpPr>
+        <p:spPr>
+          <a:xfrm>
+            <a:off x="457200" y="5010912"/>
+            <a:ext cx="1188720" cy="228600"/>
+          </a:xfrm>
+          <a:prstGeom prst="rect">
+            <a:avLst/>
+          </a:prstGeom>
+          <a:noFill/>
+        </p:spPr>
+        <p:txBody>
+          <a:bodyPr wrap="square">
+            <a:spAutoFit/>
+          </a:bodyPr>
+          <a:lstStyle/>
+          <a:p>
+            <a:pPr algn="l">
+              <a:defRPr sz="800" b="0">
+                <a:solidFill>
+                  <a:srgbClr val="0F172A"/>
+                </a:solidFill>
+              </a:defRPr>
+            </a:pPr>
+            <a:r>
+              <a:t>J5 (10 avr)</a:t>
+            </a:r>
+          </a:p>
+        </p:txBody>
+      </p:sp>
+      <p:sp>
+        <p:nvSpPr>
+          <p:cNvPr id="24" name="Rounded Rectangle 23"/>
+          <p:cNvSpPr/>
+          <p:nvPr/>
+        </p:nvSpPr>
+        <p:spPr>
+          <a:xfrm>
+            <a:off x="1691640" y="5029200"/>
+            <a:ext cx="4220307" cy="182880"/>
+          </a:xfrm>
+          <a:prstGeom prst="roundRect">
+            <a:avLst>
+              <a:gd name="adj" fmla="val 15000"/>
+            </a:avLst>
+          </a:prstGeom>
+          <a:solidFill>
+            <a:srgbClr val="00D4AA"/>
+          </a:solidFill>
+          <a:ln>
+            <a:noFill/>
+          </a:ln>
+        </p:spPr>
+        <p:style>
+          <a:lnRef idx="1">
+            <a:schemeClr val="accent1"/>
+          </a:lnRef>
+          <a:fillRef idx="3">
+            <a:schemeClr val="accent1"/>
+          </a:fillRef>
+          <a:effectRef idx="2">
+            <a:schemeClr val="accent1"/>
+          </a:effectRef>
+          <a:fontRef idx="minor">
+            <a:schemeClr val="lt1"/>
+          </a:fontRef>
+        </p:style>
+        <p:txBody>
+          <a:bodyPr rtlCol="0" anchor="ctr"/>
+          <a:lstStyle/>
+          <a:p>
+            <a:pPr algn="ctr"/>
+          </a:p>
+        </p:txBody>
+      </p:sp>
+      <p:sp>
+        <p:nvSpPr>
+          <p:cNvPr id="25" name="TextBox 24"/>
+          <p:cNvSpPr txBox="1"/>
+          <p:nvPr/>
+        </p:nvSpPr>
+        <p:spPr>
+          <a:xfrm>
+            <a:off x="6003387" y="5010912"/>
+            <a:ext cx="731520" cy="228600"/>
+          </a:xfrm>
+          <a:prstGeom prst="rect">
+            <a:avLst/>
+          </a:prstGeom>
+          <a:noFill/>
+        </p:spPr>
+        <p:txBody>
+          <a:bodyPr wrap="square">
+            <a:spAutoFit/>
+          </a:bodyPr>
+          <a:lstStyle/>
+          <a:p>
+            <a:pPr algn="l">
+              <a:defRPr sz="700" b="1">
+                <a:solidFill>
+                  <a:srgbClr val="0F172A"/>
+                </a:solidFill>
+              </a:defRPr>
+            </a:pPr>
+            <a:r>
+              <a:t>480 sess.</a:t>
+            </a:r>
+          </a:p>
+        </p:txBody>
+      </p:sp>
+      <p:sp>
+        <p:nvSpPr>
+          <p:cNvPr id="26" name="TextBox 25"/>
+          <p:cNvSpPr txBox="1"/>
+          <p:nvPr/>
+        </p:nvSpPr>
+        <p:spPr>
+          <a:xfrm>
+            <a:off x="457200" y="5303520"/>
+            <a:ext cx="1188720" cy="228600"/>
+          </a:xfrm>
+          <a:prstGeom prst="rect">
+            <a:avLst/>
+          </a:prstGeom>
+          <a:noFill/>
+        </p:spPr>
+        <p:txBody>
+          <a:bodyPr wrap="square">
+            <a:spAutoFit/>
+          </a:bodyPr>
+          <a:lstStyle/>
+          <a:p>
+            <a:pPr algn="l">
+              <a:defRPr sz="800" b="0">
+                <a:solidFill>
+                  <a:srgbClr val="0F172A"/>
+                </a:solidFill>
+              </a:defRPr>
+            </a:pPr>
+            <a:r>
+              <a:t>J6 (11 avr)</a:t>
+            </a:r>
+          </a:p>
+        </p:txBody>
+      </p:sp>
+      <p:sp>
+        <p:nvSpPr>
+          <p:cNvPr id="27" name="Rounded Rectangle 26"/>
+          <p:cNvSpPr/>
+          <p:nvPr/>
+        </p:nvSpPr>
+        <p:spPr>
+          <a:xfrm>
+            <a:off x="1691640" y="5321808"/>
+            <a:ext cx="3604846" cy="182880"/>
+          </a:xfrm>
+          <a:prstGeom prst="roundRect">
+            <a:avLst>
+              <a:gd name="adj" fmla="val 15000"/>
+            </a:avLst>
+          </a:prstGeom>
+          <a:solidFill>
+            <a:srgbClr val="3B82F6"/>
+          </a:solidFill>
+          <a:ln>
+            <a:noFill/>
+          </a:ln>
+        </p:spPr>
+        <p:style>
+          <a:lnRef idx="1">
+            <a:schemeClr val="accent1"/>
+          </a:lnRef>
+          <a:fillRef idx="3">
+            <a:schemeClr val="accent1"/>
+          </a:fillRef>
+          <a:effectRef idx="2">
+            <a:schemeClr val="accent1"/>
+          </a:effectRef>
+          <a:fontRef idx="minor">
+            <a:schemeClr val="lt1"/>
+          </a:fontRef>
+        </p:style>
+        <p:txBody>
+          <a:bodyPr rtlCol="0" anchor="ctr"/>
+          <a:lstStyle/>
+          <a:p>
+            <a:pPr algn="ctr"/>
+          </a:p>
+        </p:txBody>
+      </p:sp>
+      <p:sp>
+        <p:nvSpPr>
+          <p:cNvPr id="28" name="TextBox 27"/>
+          <p:cNvSpPr txBox="1"/>
+          <p:nvPr/>
+        </p:nvSpPr>
+        <p:spPr>
+          <a:xfrm>
+            <a:off x="5387926" y="5303520"/>
+            <a:ext cx="731520" cy="228600"/>
+          </a:xfrm>
+          <a:prstGeom prst="rect">
+            <a:avLst/>
+          </a:prstGeom>
+          <a:noFill/>
+        </p:spPr>
+        <p:txBody>
+          <a:bodyPr wrap="square">
+            <a:spAutoFit/>
+          </a:bodyPr>
+          <a:lstStyle/>
+          <a:p>
+            <a:pPr algn="l">
+              <a:defRPr sz="700" b="1">
+                <a:solidFill>
+                  <a:srgbClr val="0F172A"/>
+                </a:solidFill>
+              </a:defRPr>
+            </a:pPr>
+            <a:r>
+              <a:t>410 sess.</a:t>
+            </a:r>
+          </a:p>
+        </p:txBody>
+      </p:sp>
+      <p:sp>
+        <p:nvSpPr>
+          <p:cNvPr id="29" name="TextBox 28"/>
+          <p:cNvSpPr txBox="1"/>
+          <p:nvPr/>
+        </p:nvSpPr>
+        <p:spPr>
+          <a:xfrm>
+            <a:off x="457200" y="5596128"/>
+            <a:ext cx="1188720" cy="228600"/>
+          </a:xfrm>
+          <a:prstGeom prst="rect">
+            <a:avLst/>
+          </a:prstGeom>
+          <a:noFill/>
+        </p:spPr>
+        <p:txBody>
+          <a:bodyPr wrap="square">
+            <a:spAutoFit/>
+          </a:bodyPr>
+          <a:lstStyle/>
+          <a:p>
+            <a:pPr algn="l">
+              <a:defRPr sz="800" b="0">
+                <a:solidFill>
+                  <a:srgbClr val="0F172A"/>
+                </a:solidFill>
+              </a:defRPr>
+            </a:pPr>
+            <a:r>
+              <a:t>J7 (12 avr)</a:t>
+            </a:r>
+          </a:p>
+        </p:txBody>
+      </p:sp>
+      <p:sp>
+        <p:nvSpPr>
+          <p:cNvPr id="30" name="Rounded Rectangle 29"/>
+          <p:cNvSpPr/>
+          <p:nvPr/>
+        </p:nvSpPr>
+        <p:spPr>
+          <a:xfrm>
+            <a:off x="1691640" y="5614416"/>
+            <a:ext cx="2998176" cy="182880"/>
+          </a:xfrm>
+          <a:prstGeom prst="roundRect">
+            <a:avLst>
+              <a:gd name="adj" fmla="val 15000"/>
+            </a:avLst>
+          </a:prstGeom>
+          <a:solidFill>
+            <a:srgbClr val="3B82F6"/>
+          </a:solidFill>
+          <a:ln>
+            <a:noFill/>
+          </a:ln>
+        </p:spPr>
+        <p:style>
+          <a:lnRef idx="1">
+            <a:schemeClr val="accent1"/>
+          </a:lnRef>
+          <a:fillRef idx="3">
+            <a:schemeClr val="accent1"/>
+          </a:fillRef>
+          <a:effectRef idx="2">
+            <a:schemeClr val="accent1"/>
+          </a:effectRef>
+          <a:fontRef idx="minor">
+            <a:schemeClr val="lt1"/>
+          </a:fontRef>
+        </p:style>
+        <p:txBody>
+          <a:bodyPr rtlCol="0" anchor="ctr"/>
+          <a:lstStyle/>
+          <a:p>
+            <a:pPr algn="ctr"/>
+          </a:p>
+        </p:txBody>
+      </p:sp>
+      <p:sp>
+        <p:nvSpPr>
+          <p:cNvPr id="31" name="TextBox 30"/>
+          <p:cNvSpPr txBox="1"/>
+          <p:nvPr/>
+        </p:nvSpPr>
+        <p:spPr>
+          <a:xfrm>
+            <a:off x="4781256" y="5596128"/>
+            <a:ext cx="731520" cy="228600"/>
+          </a:xfrm>
+          <a:prstGeom prst="rect">
+            <a:avLst/>
+          </a:prstGeom>
+          <a:noFill/>
+        </p:spPr>
+        <p:txBody>
+          <a:bodyPr wrap="square">
+            <a:spAutoFit/>
+          </a:bodyPr>
+          <a:lstStyle/>
+          <a:p>
+            <a:pPr algn="l">
+              <a:defRPr sz="700" b="1">
+                <a:solidFill>
+                  <a:srgbClr val="0F172A"/>
+                </a:solidFill>
+              </a:defRPr>
+            </a:pPr>
+            <a:r>
+              <a:t>341 sess.</a:t>
+            </a:r>
+          </a:p>
+        </p:txBody>
+      </p:sp>
+      <p:sp>
+        <p:nvSpPr>
+          <p:cNvPr id="32" name="TextBox 31"/>
+          <p:cNvSpPr txBox="1"/>
+          <p:nvPr/>
+        </p:nvSpPr>
+        <p:spPr>
+          <a:xfrm>
+            <a:off x="365760" y="5943600"/>
+            <a:ext cx="8229600" cy="182880"/>
+          </a:xfrm>
+          <a:prstGeom prst="rect">
+            <a:avLst/>
+          </a:prstGeom>
+          <a:noFill/>
+        </p:spPr>
+        <p:txBody>
+          <a:bodyPr wrap="square">
+            <a:spAutoFit/>
+          </a:bodyPr>
+          <a:lstStyle/>
+          <a:p>
+            <a:pPr algn="l">
+              <a:defRPr sz="800" b="1">
+                <a:solidFill>
+                  <a:srgbClr val="00D4AA"/>
+                </a:solidFill>
+              </a:defRPr>
+            </a:pPr>
+            <a:r>
+              <a:t>▲ Pic J4 (9 avril) : +189% vs J1 — effet du lancement LinkedIn + partage communauté</a:t>
+            </a:r>
+          </a:p>
+        </p:txBody>
+      </p:sp>
+      <p:sp>
+        <p:nvSpPr>
+          <p:cNvPr id="33" name="Rounded Rectangle 32"/>
+          <p:cNvSpPr/>
+          <p:nvPr/>
+        </p:nvSpPr>
+        <p:spPr>
+          <a:xfrm>
+            <a:off x="365760" y="6217920"/>
+            <a:ext cx="8412480" cy="502920"/>
           </a:xfrm>
           <a:prstGeom prst="roundRect">
             <a:avLst>
@@ -10474,14 +10940,14 @@
       </p:sp>
       <p:sp>
         <p:nvSpPr>
-          <p:cNvPr id="12" name="Rectangle 11"/>
+          <p:cNvPr id="34" name="Rectangle 33"/>
           <p:cNvSpPr/>
           <p:nvPr/>
         </p:nvSpPr>
         <p:spPr>
           <a:xfrm>
-            <a:off x="365760" y="6126480"/>
-            <a:ext cx="50800" cy="594360"/>
+            <a:off x="365760" y="6217920"/>
+            <a:ext cx="50800" cy="502920"/>
           </a:xfrm>
           <a:prstGeom prst="rect">
             <a:avLst/>
@@ -10517,13 +10983,13 @@
       </p:sp>
       <p:sp>
         <p:nvSpPr>
-          <p:cNvPr id="13" name="TextBox 12"/>
-          <p:cNvSpPr txBox="1"/>
-          <p:nvPr/>
-        </p:nvSpPr>
-        <p:spPr>
-          <a:xfrm>
-            <a:off x="548640" y="6144768"/>
+          <p:cNvPr id="35" name="TextBox 34"/>
+          <p:cNvSpPr txBox="1"/>
+          <p:nvPr/>
+        </p:nvSpPr>
+        <p:spPr>
+          <a:xfrm>
+            <a:off x="548640" y="6236208"/>
             <a:ext cx="1828800" cy="182880"/>
           </a:xfrm>
           <a:prstGeom prst="rect">
@@ -10552,14 +11018,14 @@
       </p:sp>
       <p:sp>
         <p:nvSpPr>
-          <p:cNvPr id="14" name="TextBox 13"/>
-          <p:cNvSpPr txBox="1"/>
-          <p:nvPr/>
-        </p:nvSpPr>
-        <p:spPr>
-          <a:xfrm>
-            <a:off x="548640" y="6355080"/>
-            <a:ext cx="8046720" cy="182880"/>
+          <p:cNvPr id="36" name="TextBox 35"/>
+          <p:cNvSpPr txBox="1"/>
+          <p:nvPr/>
+        </p:nvSpPr>
+        <p:spPr>
+          <a:xfrm>
+            <a:off x="548640" y="6419088"/>
+            <a:ext cx="8046720" cy="320040"/>
           </a:xfrm>
           <a:prstGeom prst="rect">
             <a:avLst/>
@@ -10573,49 +11039,14 @@
           <a:lstStyle/>
           <a:p>
             <a:pPr algn="l">
-              <a:defRPr sz="900" b="0">
+              <a:defRPr sz="850" b="0">
                 <a:solidFill>
                   <a:srgbClr val="334155"/>
                 </a:solidFill>
               </a:defRPr>
             </a:pPr>
             <a:r>
-              <a:t>44 inscriptions effectives sur la plateforme en 7 jours.</a:t>
-            </a:r>
-          </a:p>
-        </p:txBody>
-      </p:sp>
-      <p:sp>
-        <p:nvSpPr>
-          <p:cNvPr id="15" name="TextBox 14"/>
-          <p:cNvSpPr txBox="1"/>
-          <p:nvPr/>
-        </p:nvSpPr>
-        <p:spPr>
-          <a:xfrm>
-            <a:off x="548640" y="6510528"/>
-            <a:ext cx="8046720" cy="182880"/>
-          </a:xfrm>
-          <a:prstGeom prst="rect">
-            <a:avLst/>
-          </a:prstGeom>
-          <a:noFill/>
-        </p:spPr>
-        <p:txBody>
-          <a:bodyPr wrap="square">
-            <a:spAutoFit/>
-          </a:bodyPr>
-          <a:lstStyle/>
-          <a:p>
-            <a:pPr algn="l">
-              <a:defRPr sz="900" b="0">
-                <a:solidFill>
-                  <a:srgbClr val="334155"/>
-                </a:solidFill>
-              </a:defRPr>
-            </a:pPr>
-            <a:r>
-              <a:t>Forte activité de navigation et de découverte — objectif : conversion des visiteurs en membres actifs.</a:t>
+              <a:t>Taux de rebond moyen de 16,6% vs 40-60% pour un SaaS B2B — les visiteurs explorent activement la plateforme. 44 inscriptions en 7 jours avec un pic à J4.</a:t>
             </a:r>
           </a:p>
         </p:txBody>
@@ -12365,6 +12796,121 @@
           </a:graphicData>
         </a:graphic>
       </p:graphicFrame>
+      <p:sp>
+        <p:nvSpPr>
+          <p:cNvPr id="39" name="Rounded Rectangle 38"/>
+          <p:cNvSpPr/>
+          <p:nvPr/>
+        </p:nvSpPr>
+        <p:spPr>
+          <a:xfrm>
+            <a:off x="365760" y="6263640"/>
+            <a:ext cx="8412480" cy="502920"/>
+          </a:xfrm>
+          <a:prstGeom prst="roundRect">
+            <a:avLst>
+              <a:gd name="adj" fmla="val 6000"/>
+            </a:avLst>
+          </a:prstGeom>
+          <a:solidFill>
+            <a:srgbClr val="8B5CF6"/>
+          </a:solidFill>
+          <a:ln>
+            <a:noFill/>
+          </a:ln>
+        </p:spPr>
+        <p:style>
+          <a:lnRef idx="1">
+            <a:schemeClr val="accent1"/>
+          </a:lnRef>
+          <a:fillRef idx="3">
+            <a:schemeClr val="accent1"/>
+          </a:fillRef>
+          <a:effectRef idx="2">
+            <a:schemeClr val="accent1"/>
+          </a:effectRef>
+          <a:fontRef idx="minor">
+            <a:schemeClr val="lt1"/>
+          </a:fontRef>
+        </p:style>
+        <p:txBody>
+          <a:bodyPr rtlCol="0" anchor="ctr"/>
+          <a:lstStyle/>
+          <a:p>
+            <a:pPr algn="ctr"/>
+          </a:p>
+        </p:txBody>
+      </p:sp>
+      <p:sp>
+        <p:nvSpPr>
+          <p:cNvPr id="40" name="TextBox 39"/>
+          <p:cNvSpPr txBox="1"/>
+          <p:nvPr/>
+        </p:nvSpPr>
+        <p:spPr>
+          <a:xfrm>
+            <a:off x="548640" y="6291072"/>
+            <a:ext cx="8046720" cy="228600"/>
+          </a:xfrm>
+          <a:prstGeom prst="rect">
+            <a:avLst/>
+          </a:prstGeom>
+          <a:noFill/>
+        </p:spPr>
+        <p:txBody>
+          <a:bodyPr wrap="square">
+            <a:spAutoFit/>
+          </a:bodyPr>
+          <a:lstStyle/>
+          <a:p>
+            <a:pPr algn="l">
+              <a:defRPr sz="1100" b="1">
+                <a:solidFill>
+                  <a:srgbClr val="FFFFFF"/>
+                </a:solidFill>
+              </a:defRPr>
+            </a:pPr>
+            <a:r>
+              <a:t>🤝  Appel aux partenaires</a:t>
+            </a:r>
+          </a:p>
+        </p:txBody>
+      </p:sp>
+      <p:sp>
+        <p:nvSpPr>
+          <p:cNvPr id="41" name="TextBox 40"/>
+          <p:cNvSpPr txBox="1"/>
+          <p:nvPr/>
+        </p:nvSpPr>
+        <p:spPr>
+          <a:xfrm>
+            <a:off x="548640" y="6510528"/>
+            <a:ext cx="8046720" cy="228600"/>
+          </a:xfrm>
+          <a:prstGeom prst="rect">
+            <a:avLst/>
+          </a:prstGeom>
+          <a:noFill/>
+        </p:spPr>
+        <p:txBody>
+          <a:bodyPr wrap="square">
+            <a:spAutoFit/>
+          </a:bodyPr>
+          <a:lstStyle/>
+          <a:p>
+            <a:pPr algn="l">
+              <a:defRPr sz="900" b="0">
+                <a:solidFill>
+                  <a:srgbClr val="E8DAFF"/>
+                </a:solidFill>
+              </a:defRPr>
+            </a:pPr>
+            <a:r>
+              <a:t>Aidez-nous à promouvoir The Pulse ! Partagez la plateforme avec vos réseaux, startups et communautés pour accélérer l’adoption.</a:t>
+            </a:r>
+          </a:p>
+        </p:txBody>
+      </p:sp>
     </p:spTree>
   </p:cSld>
   <p:clrMapOvr>
@@ -15483,9 +16029,2072 @@
           </a:graphicData>
         </a:graphic>
       </p:graphicFrame>
-      <p:sp>
-        <p:nvSpPr>
-          <p:cNvPr id="21" name="TextBox 20"/>
+    </p:spTree>
+  </p:cSld>
+  <p:clrMapOvr>
+    <a:masterClrMapping/>
+  </p:clrMapOvr>
+</p:sld>
+</file>
+
+<file path=ppt/slides/slide8.xml><?xml version="1.0" encoding="utf-8"?>
+<p:sld xmlns:a="http://schemas.openxmlformats.org/drawingml/2006/main" xmlns:p="http://schemas.openxmlformats.org/presentationml/2006/main" xmlns:r="http://schemas.openxmlformats.org/officeDocument/2006/relationships">
+  <p:cSld>
+    <p:bg>
+      <p:bgPr>
+        <a:solidFill>
+          <a:srgbClr val="F8FAFC"/>
+        </a:solidFill>
+        <a:effectLst/>
+      </p:bgPr>
+    </p:bg>
+    <p:spTree>
+      <p:nvGrpSpPr>
+        <p:cNvPr id="1" name=""/>
+        <p:cNvGrpSpPr/>
+        <p:nvPr/>
+      </p:nvGrpSpPr>
+      <p:grpSpPr/>
+      <p:sp>
+        <p:nvSpPr>
+          <p:cNvPr id="2" name="Rectangle 1"/>
+          <p:cNvSpPr/>
+          <p:nvPr/>
+        </p:nvSpPr>
+        <p:spPr>
+          <a:xfrm>
+            <a:off x="0" y="0"/>
+            <a:ext cx="9144000" cy="502920"/>
+          </a:xfrm>
+          <a:prstGeom prst="rect">
+            <a:avLst/>
+          </a:prstGeom>
+          <a:solidFill>
+            <a:srgbClr val="0F172A"/>
+          </a:solidFill>
+          <a:ln>
+            <a:noFill/>
+          </a:ln>
+        </p:spPr>
+        <p:style>
+          <a:lnRef idx="1">
+            <a:schemeClr val="accent1"/>
+          </a:lnRef>
+          <a:fillRef idx="3">
+            <a:schemeClr val="accent1"/>
+          </a:fillRef>
+          <a:effectRef idx="2">
+            <a:schemeClr val="accent1"/>
+          </a:effectRef>
+          <a:fontRef idx="minor">
+            <a:schemeClr val="lt1"/>
+          </a:fontRef>
+        </p:style>
+        <p:txBody>
+          <a:bodyPr rtlCol="0" anchor="ctr"/>
+          <a:lstStyle/>
+          <a:p>
+            <a:pPr algn="ctr"/>
+          </a:p>
+        </p:txBody>
+      </p:sp>
+      <p:sp>
+        <p:nvSpPr>
+          <p:cNvPr id="3" name="Rectangle 2"/>
+          <p:cNvSpPr/>
+          <p:nvPr/>
+        </p:nvSpPr>
+        <p:spPr>
+          <a:xfrm>
+            <a:off x="0" y="502920"/>
+            <a:ext cx="9144000" cy="50800"/>
+          </a:xfrm>
+          <a:prstGeom prst="rect">
+            <a:avLst/>
+          </a:prstGeom>
+          <a:solidFill>
+            <a:srgbClr val="00D4AA"/>
+          </a:solidFill>
+          <a:ln>
+            <a:noFill/>
+          </a:ln>
+        </p:spPr>
+        <p:style>
+          <a:lnRef idx="1">
+            <a:schemeClr val="accent1"/>
+          </a:lnRef>
+          <a:fillRef idx="3">
+            <a:schemeClr val="accent1"/>
+          </a:fillRef>
+          <a:effectRef idx="2">
+            <a:schemeClr val="accent1"/>
+          </a:effectRef>
+          <a:fontRef idx="minor">
+            <a:schemeClr val="lt1"/>
+          </a:fontRef>
+        </p:style>
+        <p:txBody>
+          <a:bodyPr rtlCol="0" anchor="ctr"/>
+          <a:lstStyle/>
+          <a:p>
+            <a:pPr algn="ctr"/>
+          </a:p>
+        </p:txBody>
+      </p:sp>
+      <p:pic>
+        <p:nvPicPr>
+          <p:cNvPr id="4" name="Picture 3" descr="thepulse-noir.png"/>
+          <p:cNvPicPr>
+            <a:picLocks noChangeAspect="1"/>
+          </p:cNvPicPr>
+          <p:nvPr/>
+        </p:nvPicPr>
+        <p:blipFill>
+          <a:blip r:embed="rId2"/>
+          <a:stretch>
+            <a:fillRect/>
+          </a:stretch>
+        </p:blipFill>
+        <p:spPr>
+          <a:xfrm>
+            <a:off x="274320" y="91440"/>
+            <a:ext cx="411480" cy="274320"/>
+          </a:xfrm>
+          <a:prstGeom prst="rect">
+            <a:avLst/>
+          </a:prstGeom>
+        </p:spPr>
+      </p:pic>
+      <p:sp>
+        <p:nvSpPr>
+          <p:cNvPr id="5" name="TextBox 4"/>
+          <p:cNvSpPr txBox="1"/>
+          <p:nvPr/>
+        </p:nvSpPr>
+        <p:spPr>
+          <a:xfrm>
+            <a:off x="1005840" y="109728"/>
+            <a:ext cx="5486400" cy="365760"/>
+          </a:xfrm>
+          <a:prstGeom prst="rect">
+            <a:avLst/>
+          </a:prstGeom>
+          <a:noFill/>
+        </p:spPr>
+        <p:txBody>
+          <a:bodyPr wrap="square">
+            <a:spAutoFit/>
+          </a:bodyPr>
+          <a:lstStyle/>
+          <a:p>
+            <a:pPr algn="l">
+              <a:defRPr sz="1400" b="1">
+                <a:solidFill>
+                  <a:srgbClr val="FFFFFF"/>
+                </a:solidFill>
+              </a:defRPr>
+            </a:pPr>
+            <a:r>
+              <a:t>7.  Accompagnement : Mentors &amp; Startups assignées</a:t>
+            </a:r>
+          </a:p>
+        </p:txBody>
+      </p:sp>
+      <p:sp>
+        <p:nvSpPr>
+          <p:cNvPr id="6" name="TextBox 5"/>
+          <p:cNvSpPr txBox="1"/>
+          <p:nvPr/>
+        </p:nvSpPr>
+        <p:spPr>
+          <a:xfrm>
+            <a:off x="6400800" y="109728"/>
+            <a:ext cx="2468880" cy="365760"/>
+          </a:xfrm>
+          <a:prstGeom prst="rect">
+            <a:avLst/>
+          </a:prstGeom>
+          <a:noFill/>
+        </p:spPr>
+        <p:txBody>
+          <a:bodyPr wrap="square">
+            <a:spAutoFit/>
+          </a:bodyPr>
+          <a:lstStyle/>
+          <a:p>
+            <a:pPr algn="r">
+              <a:defRPr sz="900" b="0">
+                <a:solidFill>
+                  <a:srgbClr val="94A3B8"/>
+                </a:solidFill>
+              </a:defRPr>
+            </a:pPr>
+            <a:r>
+              <a:t>Programme de mentorat</a:t>
+            </a:r>
+          </a:p>
+        </p:txBody>
+      </p:sp>
+      <p:sp>
+        <p:nvSpPr>
+          <p:cNvPr id="7" name="TextBox 6"/>
+          <p:cNvSpPr txBox="1"/>
+          <p:nvPr/>
+        </p:nvSpPr>
+        <p:spPr>
+          <a:xfrm>
+            <a:off x="365760" y="685800"/>
+            <a:ext cx="8229600" cy="274320"/>
+          </a:xfrm>
+          <a:prstGeom prst="rect">
+            <a:avLst/>
+          </a:prstGeom>
+          <a:noFill/>
+        </p:spPr>
+        <p:txBody>
+          <a:bodyPr wrap="square">
+            <a:spAutoFit/>
+          </a:bodyPr>
+          <a:lstStyle/>
+          <a:p>
+            <a:pPr algn="l">
+              <a:defRPr sz="1300" b="1">
+                <a:solidFill>
+                  <a:srgbClr val="0F172A"/>
+                </a:solidFill>
+              </a:defRPr>
+            </a:pPr>
+            <a:r>
+              <a:t>Assignation Mentors — Startups</a:t>
+            </a:r>
+          </a:p>
+        </p:txBody>
+      </p:sp>
+      <p:sp>
+        <p:nvSpPr>
+          <p:cNvPr id="8" name="TextBox 7"/>
+          <p:cNvSpPr txBox="1"/>
+          <p:nvPr/>
+        </p:nvSpPr>
+        <p:spPr>
+          <a:xfrm>
+            <a:off x="365760" y="960120"/>
+            <a:ext cx="8229600" cy="228600"/>
+          </a:xfrm>
+          <a:prstGeom prst="rect">
+            <a:avLst/>
+          </a:prstGeom>
+          <a:noFill/>
+        </p:spPr>
+        <p:txBody>
+          <a:bodyPr wrap="square">
+            <a:spAutoFit/>
+          </a:bodyPr>
+          <a:lstStyle/>
+          <a:p>
+            <a:pPr algn="l">
+              <a:defRPr sz="900" b="0">
+                <a:solidFill>
+                  <a:srgbClr val="64748B"/>
+                </a:solidFill>
+              </a:defRPr>
+            </a:pPr>
+            <a:r>
+              <a:t>Chaque mentor accompagne un portefeuille de startups sélectionnées pour un suivi personnalisé.</a:t>
+            </a:r>
+          </a:p>
+        </p:txBody>
+      </p:sp>
+      <p:sp>
+        <p:nvSpPr>
+          <p:cNvPr id="9" name="Rounded Rectangle 8"/>
+          <p:cNvSpPr/>
+          <p:nvPr/>
+        </p:nvSpPr>
+        <p:spPr>
+          <a:xfrm>
+            <a:off x="365760" y="1325880"/>
+            <a:ext cx="4114800" cy="2286000"/>
+          </a:xfrm>
+          <a:prstGeom prst="roundRect">
+            <a:avLst>
+              <a:gd name="adj" fmla="val 5000"/>
+            </a:avLst>
+          </a:prstGeom>
+          <a:solidFill>
+            <a:srgbClr val="FFFFFF"/>
+          </a:solidFill>
+          <a:ln>
+            <a:noFill/>
+          </a:ln>
+        </p:spPr>
+        <p:style>
+          <a:lnRef idx="1">
+            <a:schemeClr val="accent1"/>
+          </a:lnRef>
+          <a:fillRef idx="3">
+            <a:schemeClr val="accent1"/>
+          </a:fillRef>
+          <a:effectRef idx="2">
+            <a:schemeClr val="accent1"/>
+          </a:effectRef>
+          <a:fontRef idx="minor">
+            <a:schemeClr val="lt1"/>
+          </a:fontRef>
+        </p:style>
+        <p:txBody>
+          <a:bodyPr rtlCol="0" anchor="ctr"/>
+          <a:lstStyle/>
+          <a:p>
+            <a:pPr algn="ctr"/>
+          </a:p>
+        </p:txBody>
+      </p:sp>
+      <p:sp>
+        <p:nvSpPr>
+          <p:cNvPr id="10" name="Rectangle 9"/>
+          <p:cNvSpPr/>
+          <p:nvPr/>
+        </p:nvSpPr>
+        <p:spPr>
+          <a:xfrm>
+            <a:off x="365760" y="1325880"/>
+            <a:ext cx="4114800" cy="63500"/>
+          </a:xfrm>
+          <a:prstGeom prst="rect">
+            <a:avLst/>
+          </a:prstGeom>
+          <a:solidFill>
+            <a:srgbClr val="8B5CF6"/>
+          </a:solidFill>
+          <a:ln>
+            <a:noFill/>
+          </a:ln>
+        </p:spPr>
+        <p:style>
+          <a:lnRef idx="1">
+            <a:schemeClr val="accent1"/>
+          </a:lnRef>
+          <a:fillRef idx="3">
+            <a:schemeClr val="accent1"/>
+          </a:fillRef>
+          <a:effectRef idx="2">
+            <a:schemeClr val="accent1"/>
+          </a:effectRef>
+          <a:fontRef idx="minor">
+            <a:schemeClr val="lt1"/>
+          </a:fontRef>
+        </p:style>
+        <p:txBody>
+          <a:bodyPr rtlCol="0" anchor="ctr"/>
+          <a:lstStyle/>
+          <a:p>
+            <a:pPr algn="ctr"/>
+          </a:p>
+        </p:txBody>
+      </p:sp>
+      <p:sp>
+        <p:nvSpPr>
+          <p:cNvPr id="11" name="TextBox 10"/>
+          <p:cNvSpPr txBox="1"/>
+          <p:nvPr/>
+        </p:nvSpPr>
+        <p:spPr>
+          <a:xfrm>
+            <a:off x="502920" y="1463040"/>
+            <a:ext cx="3840480" cy="320040"/>
+          </a:xfrm>
+          <a:prstGeom prst="rect">
+            <a:avLst/>
+          </a:prstGeom>
+          <a:noFill/>
+        </p:spPr>
+        <p:txBody>
+          <a:bodyPr wrap="square">
+            <a:spAutoFit/>
+          </a:bodyPr>
+          <a:lstStyle/>
+          <a:p>
+            <a:pPr algn="l">
+              <a:defRPr sz="1400" b="1">
+                <a:solidFill>
+                  <a:srgbClr val="0F172A"/>
+                </a:solidFill>
+              </a:defRPr>
+            </a:pPr>
+            <a:r>
+              <a:t>Ali El Amrani</a:t>
+            </a:r>
+          </a:p>
+        </p:txBody>
+      </p:sp>
+      <p:sp>
+        <p:nvSpPr>
+          <p:cNvPr id="12" name="TextBox 11"/>
+          <p:cNvSpPr txBox="1"/>
+          <p:nvPr/>
+        </p:nvSpPr>
+        <p:spPr>
+          <a:xfrm>
+            <a:off x="502920" y="1737360"/>
+            <a:ext cx="3840480" cy="182880"/>
+          </a:xfrm>
+          <a:prstGeom prst="rect">
+            <a:avLst/>
+          </a:prstGeom>
+          <a:noFill/>
+        </p:spPr>
+        <p:txBody>
+          <a:bodyPr wrap="square">
+            <a:spAutoFit/>
+          </a:bodyPr>
+          <a:lstStyle/>
+          <a:p>
+            <a:pPr algn="l">
+              <a:defRPr sz="800" b="0">
+                <a:solidFill>
+                  <a:srgbClr val="64748B"/>
+                </a:solidFill>
+              </a:defRPr>
+            </a:pPr>
+            <a:r>
+              <a:t>Mentor  —  4 startups assignées</a:t>
+            </a:r>
+          </a:p>
+        </p:txBody>
+      </p:sp>
+      <p:sp>
+        <p:nvSpPr>
+          <p:cNvPr id="13" name="Rounded Rectangle 12"/>
+          <p:cNvSpPr/>
+          <p:nvPr/>
+        </p:nvSpPr>
+        <p:spPr>
+          <a:xfrm>
+            <a:off x="548640" y="2057400"/>
+            <a:ext cx="109728" cy="109728"/>
+          </a:xfrm>
+          <a:prstGeom prst="roundRect">
+            <a:avLst>
+              <a:gd name="adj" fmla="val 50000"/>
+            </a:avLst>
+          </a:prstGeom>
+          <a:solidFill>
+            <a:srgbClr val="8B5CF6"/>
+          </a:solidFill>
+          <a:ln>
+            <a:noFill/>
+          </a:ln>
+        </p:spPr>
+        <p:style>
+          <a:lnRef idx="1">
+            <a:schemeClr val="accent1"/>
+          </a:lnRef>
+          <a:fillRef idx="3">
+            <a:schemeClr val="accent1"/>
+          </a:fillRef>
+          <a:effectRef idx="2">
+            <a:schemeClr val="accent1"/>
+          </a:effectRef>
+          <a:fontRef idx="minor">
+            <a:schemeClr val="lt1"/>
+          </a:fontRef>
+        </p:style>
+        <p:txBody>
+          <a:bodyPr rtlCol="0" anchor="ctr"/>
+          <a:lstStyle/>
+          <a:p>
+            <a:pPr algn="ctr"/>
+          </a:p>
+        </p:txBody>
+      </p:sp>
+      <p:sp>
+        <p:nvSpPr>
+          <p:cNvPr id="14" name="TextBox 13"/>
+          <p:cNvSpPr txBox="1"/>
+          <p:nvPr/>
+        </p:nvSpPr>
+        <p:spPr>
+          <a:xfrm>
+            <a:off x="731520" y="2011680"/>
+            <a:ext cx="3566160" cy="228600"/>
+          </a:xfrm>
+          <a:prstGeom prst="rect">
+            <a:avLst/>
+          </a:prstGeom>
+          <a:noFill/>
+        </p:spPr>
+        <p:txBody>
+          <a:bodyPr wrap="square">
+            <a:spAutoFit/>
+          </a:bodyPr>
+          <a:lstStyle/>
+          <a:p>
+            <a:pPr algn="l">
+              <a:defRPr sz="1000" b="0">
+                <a:solidFill>
+                  <a:srgbClr val="0F172A"/>
+                </a:solidFill>
+              </a:defRPr>
+            </a:pPr>
+            <a:r>
+              <a:t>IndusTwin</a:t>
+            </a:r>
+          </a:p>
+        </p:txBody>
+      </p:sp>
+      <p:sp>
+        <p:nvSpPr>
+          <p:cNvPr id="15" name="Rounded Rectangle 14"/>
+          <p:cNvSpPr/>
+          <p:nvPr/>
+        </p:nvSpPr>
+        <p:spPr>
+          <a:xfrm>
+            <a:off x="548640" y="2331720"/>
+            <a:ext cx="109728" cy="109728"/>
+          </a:xfrm>
+          <a:prstGeom prst="roundRect">
+            <a:avLst>
+              <a:gd name="adj" fmla="val 50000"/>
+            </a:avLst>
+          </a:prstGeom>
+          <a:solidFill>
+            <a:srgbClr val="8B5CF6"/>
+          </a:solidFill>
+          <a:ln>
+            <a:noFill/>
+          </a:ln>
+        </p:spPr>
+        <p:style>
+          <a:lnRef idx="1">
+            <a:schemeClr val="accent1"/>
+          </a:lnRef>
+          <a:fillRef idx="3">
+            <a:schemeClr val="accent1"/>
+          </a:fillRef>
+          <a:effectRef idx="2">
+            <a:schemeClr val="accent1"/>
+          </a:effectRef>
+          <a:fontRef idx="minor">
+            <a:schemeClr val="lt1"/>
+          </a:fontRef>
+        </p:style>
+        <p:txBody>
+          <a:bodyPr rtlCol="0" anchor="ctr"/>
+          <a:lstStyle/>
+          <a:p>
+            <a:pPr algn="ctr"/>
+          </a:p>
+        </p:txBody>
+      </p:sp>
+      <p:sp>
+        <p:nvSpPr>
+          <p:cNvPr id="16" name="TextBox 15"/>
+          <p:cNvSpPr txBox="1"/>
+          <p:nvPr/>
+        </p:nvSpPr>
+        <p:spPr>
+          <a:xfrm>
+            <a:off x="731520" y="2286000"/>
+            <a:ext cx="3566160" cy="228600"/>
+          </a:xfrm>
+          <a:prstGeom prst="rect">
+            <a:avLst/>
+          </a:prstGeom>
+          <a:noFill/>
+        </p:spPr>
+        <p:txBody>
+          <a:bodyPr wrap="square">
+            <a:spAutoFit/>
+          </a:bodyPr>
+          <a:lstStyle/>
+          <a:p>
+            <a:pPr algn="l">
+              <a:defRPr sz="1000" b="0">
+                <a:solidFill>
+                  <a:srgbClr val="0F172A"/>
+                </a:solidFill>
+              </a:defRPr>
+            </a:pPr>
+            <a:r>
+              <a:t>IrrigSense</a:t>
+            </a:r>
+          </a:p>
+        </p:txBody>
+      </p:sp>
+      <p:sp>
+        <p:nvSpPr>
+          <p:cNvPr id="17" name="Rounded Rectangle 16"/>
+          <p:cNvSpPr/>
+          <p:nvPr/>
+        </p:nvSpPr>
+        <p:spPr>
+          <a:xfrm>
+            <a:off x="548640" y="2606040"/>
+            <a:ext cx="109728" cy="109728"/>
+          </a:xfrm>
+          <a:prstGeom prst="roundRect">
+            <a:avLst>
+              <a:gd name="adj" fmla="val 50000"/>
+            </a:avLst>
+          </a:prstGeom>
+          <a:solidFill>
+            <a:srgbClr val="8B5CF6"/>
+          </a:solidFill>
+          <a:ln>
+            <a:noFill/>
+          </a:ln>
+        </p:spPr>
+        <p:style>
+          <a:lnRef idx="1">
+            <a:schemeClr val="accent1"/>
+          </a:lnRef>
+          <a:fillRef idx="3">
+            <a:schemeClr val="accent1"/>
+          </a:fillRef>
+          <a:effectRef idx="2">
+            <a:schemeClr val="accent1"/>
+          </a:effectRef>
+          <a:fontRef idx="minor">
+            <a:schemeClr val="lt1"/>
+          </a:fontRef>
+        </p:style>
+        <p:txBody>
+          <a:bodyPr rtlCol="0" anchor="ctr"/>
+          <a:lstStyle/>
+          <a:p>
+            <a:pPr algn="ctr"/>
+          </a:p>
+        </p:txBody>
+      </p:sp>
+      <p:sp>
+        <p:nvSpPr>
+          <p:cNvPr id="18" name="TextBox 17"/>
+          <p:cNvSpPr txBox="1"/>
+          <p:nvPr/>
+        </p:nvSpPr>
+        <p:spPr>
+          <a:xfrm>
+            <a:off x="731520" y="2560320"/>
+            <a:ext cx="3566160" cy="228600"/>
+          </a:xfrm>
+          <a:prstGeom prst="rect">
+            <a:avLst/>
+          </a:prstGeom>
+          <a:noFill/>
+        </p:spPr>
+        <p:txBody>
+          <a:bodyPr wrap="square">
+            <a:spAutoFit/>
+          </a:bodyPr>
+          <a:lstStyle/>
+          <a:p>
+            <a:pPr algn="l">
+              <a:defRPr sz="1000" b="0">
+                <a:solidFill>
+                  <a:srgbClr val="0F172A"/>
+                </a:solidFill>
+              </a:defRPr>
+            </a:pPr>
+            <a:r>
+              <a:t>AeroMind Morocco</a:t>
+            </a:r>
+          </a:p>
+        </p:txBody>
+      </p:sp>
+      <p:sp>
+        <p:nvSpPr>
+          <p:cNvPr id="19" name="Rounded Rectangle 18"/>
+          <p:cNvSpPr/>
+          <p:nvPr/>
+        </p:nvSpPr>
+        <p:spPr>
+          <a:xfrm>
+            <a:off x="548640" y="2880360"/>
+            <a:ext cx="109728" cy="109728"/>
+          </a:xfrm>
+          <a:prstGeom prst="roundRect">
+            <a:avLst>
+              <a:gd name="adj" fmla="val 50000"/>
+            </a:avLst>
+          </a:prstGeom>
+          <a:solidFill>
+            <a:srgbClr val="8B5CF6"/>
+          </a:solidFill>
+          <a:ln>
+            <a:noFill/>
+          </a:ln>
+        </p:spPr>
+        <p:style>
+          <a:lnRef idx="1">
+            <a:schemeClr val="accent1"/>
+          </a:lnRef>
+          <a:fillRef idx="3">
+            <a:schemeClr val="accent1"/>
+          </a:fillRef>
+          <a:effectRef idx="2">
+            <a:schemeClr val="accent1"/>
+          </a:effectRef>
+          <a:fontRef idx="minor">
+            <a:schemeClr val="lt1"/>
+          </a:fontRef>
+        </p:style>
+        <p:txBody>
+          <a:bodyPr rtlCol="0" anchor="ctr"/>
+          <a:lstStyle/>
+          <a:p>
+            <a:pPr algn="ctr"/>
+          </a:p>
+        </p:txBody>
+      </p:sp>
+      <p:sp>
+        <p:nvSpPr>
+          <p:cNvPr id="20" name="TextBox 19"/>
+          <p:cNvSpPr txBox="1"/>
+          <p:nvPr/>
+        </p:nvSpPr>
+        <p:spPr>
+          <a:xfrm>
+            <a:off x="731520" y="2834640"/>
+            <a:ext cx="3566160" cy="228600"/>
+          </a:xfrm>
+          <a:prstGeom prst="rect">
+            <a:avLst/>
+          </a:prstGeom>
+          <a:noFill/>
+        </p:spPr>
+        <p:txBody>
+          <a:bodyPr wrap="square">
+            <a:spAutoFit/>
+          </a:bodyPr>
+          <a:lstStyle/>
+          <a:p>
+            <a:pPr algn="l">
+              <a:defRPr sz="1000" b="0">
+                <a:solidFill>
+                  <a:srgbClr val="0F172A"/>
+                </a:solidFill>
+              </a:defRPr>
+            </a:pPr>
+            <a:r>
+              <a:t>WAHGO Foods</a:t>
+            </a:r>
+          </a:p>
+        </p:txBody>
+      </p:sp>
+      <p:sp>
+        <p:nvSpPr>
+          <p:cNvPr id="21" name="Rounded Rectangle 20"/>
+          <p:cNvSpPr/>
+          <p:nvPr/>
+        </p:nvSpPr>
+        <p:spPr>
+          <a:xfrm>
+            <a:off x="4663440" y="1325880"/>
+            <a:ext cx="4114800" cy="2286000"/>
+          </a:xfrm>
+          <a:prstGeom prst="roundRect">
+            <a:avLst>
+              <a:gd name="adj" fmla="val 5000"/>
+            </a:avLst>
+          </a:prstGeom>
+          <a:solidFill>
+            <a:srgbClr val="FFFFFF"/>
+          </a:solidFill>
+          <a:ln>
+            <a:noFill/>
+          </a:ln>
+        </p:spPr>
+        <p:style>
+          <a:lnRef idx="1">
+            <a:schemeClr val="accent1"/>
+          </a:lnRef>
+          <a:fillRef idx="3">
+            <a:schemeClr val="accent1"/>
+          </a:fillRef>
+          <a:effectRef idx="2">
+            <a:schemeClr val="accent1"/>
+          </a:effectRef>
+          <a:fontRef idx="minor">
+            <a:schemeClr val="lt1"/>
+          </a:fontRef>
+        </p:style>
+        <p:txBody>
+          <a:bodyPr rtlCol="0" anchor="ctr"/>
+          <a:lstStyle/>
+          <a:p>
+            <a:pPr algn="ctr"/>
+          </a:p>
+        </p:txBody>
+      </p:sp>
+      <p:sp>
+        <p:nvSpPr>
+          <p:cNvPr id="22" name="Rectangle 21"/>
+          <p:cNvSpPr/>
+          <p:nvPr/>
+        </p:nvSpPr>
+        <p:spPr>
+          <a:xfrm>
+            <a:off x="4663440" y="1325880"/>
+            <a:ext cx="4114800" cy="63500"/>
+          </a:xfrm>
+          <a:prstGeom prst="rect">
+            <a:avLst/>
+          </a:prstGeom>
+          <a:solidFill>
+            <a:srgbClr val="00D4AA"/>
+          </a:solidFill>
+          <a:ln>
+            <a:noFill/>
+          </a:ln>
+        </p:spPr>
+        <p:style>
+          <a:lnRef idx="1">
+            <a:schemeClr val="accent1"/>
+          </a:lnRef>
+          <a:fillRef idx="3">
+            <a:schemeClr val="accent1"/>
+          </a:fillRef>
+          <a:effectRef idx="2">
+            <a:schemeClr val="accent1"/>
+          </a:effectRef>
+          <a:fontRef idx="minor">
+            <a:schemeClr val="lt1"/>
+          </a:fontRef>
+        </p:style>
+        <p:txBody>
+          <a:bodyPr rtlCol="0" anchor="ctr"/>
+          <a:lstStyle/>
+          <a:p>
+            <a:pPr algn="ctr"/>
+          </a:p>
+        </p:txBody>
+      </p:sp>
+      <p:sp>
+        <p:nvSpPr>
+          <p:cNvPr id="23" name="TextBox 22"/>
+          <p:cNvSpPr txBox="1"/>
+          <p:nvPr/>
+        </p:nvSpPr>
+        <p:spPr>
+          <a:xfrm>
+            <a:off x="4800600" y="1463040"/>
+            <a:ext cx="3840480" cy="320040"/>
+          </a:xfrm>
+          <a:prstGeom prst="rect">
+            <a:avLst/>
+          </a:prstGeom>
+          <a:noFill/>
+        </p:spPr>
+        <p:txBody>
+          <a:bodyPr wrap="square">
+            <a:spAutoFit/>
+          </a:bodyPr>
+          <a:lstStyle/>
+          <a:p>
+            <a:pPr algn="l">
+              <a:defRPr sz="1400" b="1">
+                <a:solidFill>
+                  <a:srgbClr val="0F172A"/>
+                </a:solidFill>
+              </a:defRPr>
+            </a:pPr>
+            <a:r>
+              <a:t>Youssef Mamou</a:t>
+            </a:r>
+          </a:p>
+        </p:txBody>
+      </p:sp>
+      <p:sp>
+        <p:nvSpPr>
+          <p:cNvPr id="24" name="TextBox 23"/>
+          <p:cNvSpPr txBox="1"/>
+          <p:nvPr/>
+        </p:nvSpPr>
+        <p:spPr>
+          <a:xfrm>
+            <a:off x="4800600" y="1737360"/>
+            <a:ext cx="3840480" cy="182880"/>
+          </a:xfrm>
+          <a:prstGeom prst="rect">
+            <a:avLst/>
+          </a:prstGeom>
+          <a:noFill/>
+        </p:spPr>
+        <p:txBody>
+          <a:bodyPr wrap="square">
+            <a:spAutoFit/>
+          </a:bodyPr>
+          <a:lstStyle/>
+          <a:p>
+            <a:pPr algn="l">
+              <a:defRPr sz="800" b="0">
+                <a:solidFill>
+                  <a:srgbClr val="64748B"/>
+                </a:solidFill>
+              </a:defRPr>
+            </a:pPr>
+            <a:r>
+              <a:t>Mentor  —  5 startups assignées</a:t>
+            </a:r>
+          </a:p>
+        </p:txBody>
+      </p:sp>
+      <p:sp>
+        <p:nvSpPr>
+          <p:cNvPr id="25" name="Rounded Rectangle 24"/>
+          <p:cNvSpPr/>
+          <p:nvPr/>
+        </p:nvSpPr>
+        <p:spPr>
+          <a:xfrm>
+            <a:off x="4846320" y="2057400"/>
+            <a:ext cx="109728" cy="109728"/>
+          </a:xfrm>
+          <a:prstGeom prst="roundRect">
+            <a:avLst>
+              <a:gd name="adj" fmla="val 50000"/>
+            </a:avLst>
+          </a:prstGeom>
+          <a:solidFill>
+            <a:srgbClr val="00D4AA"/>
+          </a:solidFill>
+          <a:ln>
+            <a:noFill/>
+          </a:ln>
+        </p:spPr>
+        <p:style>
+          <a:lnRef idx="1">
+            <a:schemeClr val="accent1"/>
+          </a:lnRef>
+          <a:fillRef idx="3">
+            <a:schemeClr val="accent1"/>
+          </a:fillRef>
+          <a:effectRef idx="2">
+            <a:schemeClr val="accent1"/>
+          </a:effectRef>
+          <a:fontRef idx="minor">
+            <a:schemeClr val="lt1"/>
+          </a:fontRef>
+        </p:style>
+        <p:txBody>
+          <a:bodyPr rtlCol="0" anchor="ctr"/>
+          <a:lstStyle/>
+          <a:p>
+            <a:pPr algn="ctr"/>
+          </a:p>
+        </p:txBody>
+      </p:sp>
+      <p:sp>
+        <p:nvSpPr>
+          <p:cNvPr id="26" name="TextBox 25"/>
+          <p:cNvSpPr txBox="1"/>
+          <p:nvPr/>
+        </p:nvSpPr>
+        <p:spPr>
+          <a:xfrm>
+            <a:off x="5029200" y="2011680"/>
+            <a:ext cx="3566160" cy="228600"/>
+          </a:xfrm>
+          <a:prstGeom prst="rect">
+            <a:avLst/>
+          </a:prstGeom>
+          <a:noFill/>
+        </p:spPr>
+        <p:txBody>
+          <a:bodyPr wrap="square">
+            <a:spAutoFit/>
+          </a:bodyPr>
+          <a:lstStyle/>
+          <a:p>
+            <a:pPr algn="l">
+              <a:defRPr sz="1000" b="0">
+                <a:solidFill>
+                  <a:srgbClr val="0F172A"/>
+                </a:solidFill>
+              </a:defRPr>
+            </a:pPr>
+            <a:r>
+              <a:t>Investing For Everyone</a:t>
+            </a:r>
+          </a:p>
+        </p:txBody>
+      </p:sp>
+      <p:sp>
+        <p:nvSpPr>
+          <p:cNvPr id="27" name="Rounded Rectangle 26"/>
+          <p:cNvSpPr/>
+          <p:nvPr/>
+        </p:nvSpPr>
+        <p:spPr>
+          <a:xfrm>
+            <a:off x="4846320" y="2331720"/>
+            <a:ext cx="109728" cy="109728"/>
+          </a:xfrm>
+          <a:prstGeom prst="roundRect">
+            <a:avLst>
+              <a:gd name="adj" fmla="val 50000"/>
+            </a:avLst>
+          </a:prstGeom>
+          <a:solidFill>
+            <a:srgbClr val="00D4AA"/>
+          </a:solidFill>
+          <a:ln>
+            <a:noFill/>
+          </a:ln>
+        </p:spPr>
+        <p:style>
+          <a:lnRef idx="1">
+            <a:schemeClr val="accent1"/>
+          </a:lnRef>
+          <a:fillRef idx="3">
+            <a:schemeClr val="accent1"/>
+          </a:fillRef>
+          <a:effectRef idx="2">
+            <a:schemeClr val="accent1"/>
+          </a:effectRef>
+          <a:fontRef idx="minor">
+            <a:schemeClr val="lt1"/>
+          </a:fontRef>
+        </p:style>
+        <p:txBody>
+          <a:bodyPr rtlCol="0" anchor="ctr"/>
+          <a:lstStyle/>
+          <a:p>
+            <a:pPr algn="ctr"/>
+          </a:p>
+        </p:txBody>
+      </p:sp>
+      <p:sp>
+        <p:nvSpPr>
+          <p:cNvPr id="28" name="TextBox 27"/>
+          <p:cNvSpPr txBox="1"/>
+          <p:nvPr/>
+        </p:nvSpPr>
+        <p:spPr>
+          <a:xfrm>
+            <a:off x="5029200" y="2286000"/>
+            <a:ext cx="3566160" cy="228600"/>
+          </a:xfrm>
+          <a:prstGeom prst="rect">
+            <a:avLst/>
+          </a:prstGeom>
+          <a:noFill/>
+        </p:spPr>
+        <p:txBody>
+          <a:bodyPr wrap="square">
+            <a:spAutoFit/>
+          </a:bodyPr>
+          <a:lstStyle/>
+          <a:p>
+            <a:pPr algn="l">
+              <a:defRPr sz="1000" b="0">
+                <a:solidFill>
+                  <a:srgbClr val="0F172A"/>
+                </a:solidFill>
+              </a:defRPr>
+            </a:pPr>
+            <a:r>
+              <a:t>Igudar</a:t>
+            </a:r>
+          </a:p>
+        </p:txBody>
+      </p:sp>
+      <p:sp>
+        <p:nvSpPr>
+          <p:cNvPr id="29" name="Rounded Rectangle 28"/>
+          <p:cNvSpPr/>
+          <p:nvPr/>
+        </p:nvSpPr>
+        <p:spPr>
+          <a:xfrm>
+            <a:off x="4846320" y="2606040"/>
+            <a:ext cx="109728" cy="109728"/>
+          </a:xfrm>
+          <a:prstGeom prst="roundRect">
+            <a:avLst>
+              <a:gd name="adj" fmla="val 50000"/>
+            </a:avLst>
+          </a:prstGeom>
+          <a:solidFill>
+            <a:srgbClr val="00D4AA"/>
+          </a:solidFill>
+          <a:ln>
+            <a:noFill/>
+          </a:ln>
+        </p:spPr>
+        <p:style>
+          <a:lnRef idx="1">
+            <a:schemeClr val="accent1"/>
+          </a:lnRef>
+          <a:fillRef idx="3">
+            <a:schemeClr val="accent1"/>
+          </a:fillRef>
+          <a:effectRef idx="2">
+            <a:schemeClr val="accent1"/>
+          </a:effectRef>
+          <a:fontRef idx="minor">
+            <a:schemeClr val="lt1"/>
+          </a:fontRef>
+        </p:style>
+        <p:txBody>
+          <a:bodyPr rtlCol="0" anchor="ctr"/>
+          <a:lstStyle/>
+          <a:p>
+            <a:pPr algn="ctr"/>
+          </a:p>
+        </p:txBody>
+      </p:sp>
+      <p:sp>
+        <p:nvSpPr>
+          <p:cNvPr id="30" name="TextBox 29"/>
+          <p:cNvSpPr txBox="1"/>
+          <p:nvPr/>
+        </p:nvSpPr>
+        <p:spPr>
+          <a:xfrm>
+            <a:off x="5029200" y="2560320"/>
+            <a:ext cx="3566160" cy="228600"/>
+          </a:xfrm>
+          <a:prstGeom prst="rect">
+            <a:avLst/>
+          </a:prstGeom>
+          <a:noFill/>
+        </p:spPr>
+        <p:txBody>
+          <a:bodyPr wrap="square">
+            <a:spAutoFit/>
+          </a:bodyPr>
+          <a:lstStyle/>
+          <a:p>
+            <a:pPr algn="l">
+              <a:defRPr sz="1000" b="0">
+                <a:solidFill>
+                  <a:srgbClr val="0F172A"/>
+                </a:solidFill>
+              </a:defRPr>
+            </a:pPr>
+            <a:r>
+              <a:t>XPredictia</a:t>
+            </a:r>
+          </a:p>
+        </p:txBody>
+      </p:sp>
+      <p:sp>
+        <p:nvSpPr>
+          <p:cNvPr id="31" name="Rounded Rectangle 30"/>
+          <p:cNvSpPr/>
+          <p:nvPr/>
+        </p:nvSpPr>
+        <p:spPr>
+          <a:xfrm>
+            <a:off x="4846320" y="2880360"/>
+            <a:ext cx="109728" cy="109728"/>
+          </a:xfrm>
+          <a:prstGeom prst="roundRect">
+            <a:avLst>
+              <a:gd name="adj" fmla="val 50000"/>
+            </a:avLst>
+          </a:prstGeom>
+          <a:solidFill>
+            <a:srgbClr val="00D4AA"/>
+          </a:solidFill>
+          <a:ln>
+            <a:noFill/>
+          </a:ln>
+        </p:spPr>
+        <p:style>
+          <a:lnRef idx="1">
+            <a:schemeClr val="accent1"/>
+          </a:lnRef>
+          <a:fillRef idx="3">
+            <a:schemeClr val="accent1"/>
+          </a:fillRef>
+          <a:effectRef idx="2">
+            <a:schemeClr val="accent1"/>
+          </a:effectRef>
+          <a:fontRef idx="minor">
+            <a:schemeClr val="lt1"/>
+          </a:fontRef>
+        </p:style>
+        <p:txBody>
+          <a:bodyPr rtlCol="0" anchor="ctr"/>
+          <a:lstStyle/>
+          <a:p>
+            <a:pPr algn="ctr"/>
+          </a:p>
+        </p:txBody>
+      </p:sp>
+      <p:sp>
+        <p:nvSpPr>
+          <p:cNvPr id="32" name="TextBox 31"/>
+          <p:cNvSpPr txBox="1"/>
+          <p:nvPr/>
+        </p:nvSpPr>
+        <p:spPr>
+          <a:xfrm>
+            <a:off x="5029200" y="2834640"/>
+            <a:ext cx="3566160" cy="228600"/>
+          </a:xfrm>
+          <a:prstGeom prst="rect">
+            <a:avLst/>
+          </a:prstGeom>
+          <a:noFill/>
+        </p:spPr>
+        <p:txBody>
+          <a:bodyPr wrap="square">
+            <a:spAutoFit/>
+          </a:bodyPr>
+          <a:lstStyle/>
+          <a:p>
+            <a:pPr algn="l">
+              <a:defRPr sz="1000" b="0">
+                <a:solidFill>
+                  <a:srgbClr val="0F172A"/>
+                </a:solidFill>
+              </a:defRPr>
+            </a:pPr>
+            <a:r>
+              <a:t>SmartDiag</a:t>
+            </a:r>
+          </a:p>
+        </p:txBody>
+      </p:sp>
+      <p:sp>
+        <p:nvSpPr>
+          <p:cNvPr id="33" name="Rounded Rectangle 32"/>
+          <p:cNvSpPr/>
+          <p:nvPr/>
+        </p:nvSpPr>
+        <p:spPr>
+          <a:xfrm>
+            <a:off x="4846320" y="3154680"/>
+            <a:ext cx="109728" cy="109728"/>
+          </a:xfrm>
+          <a:prstGeom prst="roundRect">
+            <a:avLst>
+              <a:gd name="adj" fmla="val 50000"/>
+            </a:avLst>
+          </a:prstGeom>
+          <a:solidFill>
+            <a:srgbClr val="00D4AA"/>
+          </a:solidFill>
+          <a:ln>
+            <a:noFill/>
+          </a:ln>
+        </p:spPr>
+        <p:style>
+          <a:lnRef idx="1">
+            <a:schemeClr val="accent1"/>
+          </a:lnRef>
+          <a:fillRef idx="3">
+            <a:schemeClr val="accent1"/>
+          </a:fillRef>
+          <a:effectRef idx="2">
+            <a:schemeClr val="accent1"/>
+          </a:effectRef>
+          <a:fontRef idx="minor">
+            <a:schemeClr val="lt1"/>
+          </a:fontRef>
+        </p:style>
+        <p:txBody>
+          <a:bodyPr rtlCol="0" anchor="ctr"/>
+          <a:lstStyle/>
+          <a:p>
+            <a:pPr algn="ctr"/>
+          </a:p>
+        </p:txBody>
+      </p:sp>
+      <p:sp>
+        <p:nvSpPr>
+          <p:cNvPr id="34" name="TextBox 33"/>
+          <p:cNvSpPr txBox="1"/>
+          <p:nvPr/>
+        </p:nvSpPr>
+        <p:spPr>
+          <a:xfrm>
+            <a:off x="5029200" y="3108960"/>
+            <a:ext cx="3566160" cy="228600"/>
+          </a:xfrm>
+          <a:prstGeom prst="rect">
+            <a:avLst/>
+          </a:prstGeom>
+          <a:noFill/>
+        </p:spPr>
+        <p:txBody>
+          <a:bodyPr wrap="square">
+            <a:spAutoFit/>
+          </a:bodyPr>
+          <a:lstStyle/>
+          <a:p>
+            <a:pPr algn="l">
+              <a:defRPr sz="1000" b="0">
+                <a:solidFill>
+                  <a:srgbClr val="0F172A"/>
+                </a:solidFill>
+              </a:defRPr>
+            </a:pPr>
+            <a:r>
+              <a:t>SyanaTek</a:t>
+            </a:r>
+          </a:p>
+        </p:txBody>
+      </p:sp>
+      <p:sp>
+        <p:nvSpPr>
+          <p:cNvPr id="35" name="Rounded Rectangle 34"/>
+          <p:cNvSpPr/>
+          <p:nvPr/>
+        </p:nvSpPr>
+        <p:spPr>
+          <a:xfrm>
+            <a:off x="365760" y="3794760"/>
+            <a:ext cx="4114800" cy="2286000"/>
+          </a:xfrm>
+          <a:prstGeom prst="roundRect">
+            <a:avLst>
+              <a:gd name="adj" fmla="val 5000"/>
+            </a:avLst>
+          </a:prstGeom>
+          <a:solidFill>
+            <a:srgbClr val="FFFFFF"/>
+          </a:solidFill>
+          <a:ln>
+            <a:noFill/>
+          </a:ln>
+        </p:spPr>
+        <p:style>
+          <a:lnRef idx="1">
+            <a:schemeClr val="accent1"/>
+          </a:lnRef>
+          <a:fillRef idx="3">
+            <a:schemeClr val="accent1"/>
+          </a:fillRef>
+          <a:effectRef idx="2">
+            <a:schemeClr val="accent1"/>
+          </a:effectRef>
+          <a:fontRef idx="minor">
+            <a:schemeClr val="lt1"/>
+          </a:fontRef>
+        </p:style>
+        <p:txBody>
+          <a:bodyPr rtlCol="0" anchor="ctr"/>
+          <a:lstStyle/>
+          <a:p>
+            <a:pPr algn="ctr"/>
+          </a:p>
+        </p:txBody>
+      </p:sp>
+      <p:sp>
+        <p:nvSpPr>
+          <p:cNvPr id="36" name="Rectangle 35"/>
+          <p:cNvSpPr/>
+          <p:nvPr/>
+        </p:nvSpPr>
+        <p:spPr>
+          <a:xfrm>
+            <a:off x="365760" y="3794760"/>
+            <a:ext cx="4114800" cy="63500"/>
+          </a:xfrm>
+          <a:prstGeom prst="rect">
+            <a:avLst/>
+          </a:prstGeom>
+          <a:solidFill>
+            <a:srgbClr val="3B82F6"/>
+          </a:solidFill>
+          <a:ln>
+            <a:noFill/>
+          </a:ln>
+        </p:spPr>
+        <p:style>
+          <a:lnRef idx="1">
+            <a:schemeClr val="accent1"/>
+          </a:lnRef>
+          <a:fillRef idx="3">
+            <a:schemeClr val="accent1"/>
+          </a:fillRef>
+          <a:effectRef idx="2">
+            <a:schemeClr val="accent1"/>
+          </a:effectRef>
+          <a:fontRef idx="minor">
+            <a:schemeClr val="lt1"/>
+          </a:fontRef>
+        </p:style>
+        <p:txBody>
+          <a:bodyPr rtlCol="0" anchor="ctr"/>
+          <a:lstStyle/>
+          <a:p>
+            <a:pPr algn="ctr"/>
+          </a:p>
+        </p:txBody>
+      </p:sp>
+      <p:sp>
+        <p:nvSpPr>
+          <p:cNvPr id="37" name="TextBox 36"/>
+          <p:cNvSpPr txBox="1"/>
+          <p:nvPr/>
+        </p:nvSpPr>
+        <p:spPr>
+          <a:xfrm>
+            <a:off x="502920" y="3931920"/>
+            <a:ext cx="3840480" cy="320040"/>
+          </a:xfrm>
+          <a:prstGeom prst="rect">
+            <a:avLst/>
+          </a:prstGeom>
+          <a:noFill/>
+        </p:spPr>
+        <p:txBody>
+          <a:bodyPr wrap="square">
+            <a:spAutoFit/>
+          </a:bodyPr>
+          <a:lstStyle/>
+          <a:p>
+            <a:pPr algn="l">
+              <a:defRPr sz="1400" b="1">
+                <a:solidFill>
+                  <a:srgbClr val="0F172A"/>
+                </a:solidFill>
+              </a:defRPr>
+            </a:pPr>
+            <a:r>
+              <a:t>Tarik Fadli</a:t>
+            </a:r>
+          </a:p>
+        </p:txBody>
+      </p:sp>
+      <p:sp>
+        <p:nvSpPr>
+          <p:cNvPr id="38" name="TextBox 37"/>
+          <p:cNvSpPr txBox="1"/>
+          <p:nvPr/>
+        </p:nvSpPr>
+        <p:spPr>
+          <a:xfrm>
+            <a:off x="502920" y="4206240"/>
+            <a:ext cx="3840480" cy="182880"/>
+          </a:xfrm>
+          <a:prstGeom prst="rect">
+            <a:avLst/>
+          </a:prstGeom>
+          <a:noFill/>
+        </p:spPr>
+        <p:txBody>
+          <a:bodyPr wrap="square">
+            <a:spAutoFit/>
+          </a:bodyPr>
+          <a:lstStyle/>
+          <a:p>
+            <a:pPr algn="l">
+              <a:defRPr sz="800" b="0">
+                <a:solidFill>
+                  <a:srgbClr val="64748B"/>
+                </a:solidFill>
+              </a:defRPr>
+            </a:pPr>
+            <a:r>
+              <a:t>Mentor  —  3 startups assignées</a:t>
+            </a:r>
+          </a:p>
+        </p:txBody>
+      </p:sp>
+      <p:sp>
+        <p:nvSpPr>
+          <p:cNvPr id="39" name="Rounded Rectangle 38"/>
+          <p:cNvSpPr/>
+          <p:nvPr/>
+        </p:nvSpPr>
+        <p:spPr>
+          <a:xfrm>
+            <a:off x="548640" y="4526280"/>
+            <a:ext cx="109728" cy="109728"/>
+          </a:xfrm>
+          <a:prstGeom prst="roundRect">
+            <a:avLst>
+              <a:gd name="adj" fmla="val 50000"/>
+            </a:avLst>
+          </a:prstGeom>
+          <a:solidFill>
+            <a:srgbClr val="3B82F6"/>
+          </a:solidFill>
+          <a:ln>
+            <a:noFill/>
+          </a:ln>
+        </p:spPr>
+        <p:style>
+          <a:lnRef idx="1">
+            <a:schemeClr val="accent1"/>
+          </a:lnRef>
+          <a:fillRef idx="3">
+            <a:schemeClr val="accent1"/>
+          </a:fillRef>
+          <a:effectRef idx="2">
+            <a:schemeClr val="accent1"/>
+          </a:effectRef>
+          <a:fontRef idx="minor">
+            <a:schemeClr val="lt1"/>
+          </a:fontRef>
+        </p:style>
+        <p:txBody>
+          <a:bodyPr rtlCol="0" anchor="ctr"/>
+          <a:lstStyle/>
+          <a:p>
+            <a:pPr algn="ctr"/>
+          </a:p>
+        </p:txBody>
+      </p:sp>
+      <p:sp>
+        <p:nvSpPr>
+          <p:cNvPr id="40" name="TextBox 39"/>
+          <p:cNvSpPr txBox="1"/>
+          <p:nvPr/>
+        </p:nvSpPr>
+        <p:spPr>
+          <a:xfrm>
+            <a:off x="731520" y="4480560"/>
+            <a:ext cx="3566160" cy="228600"/>
+          </a:xfrm>
+          <a:prstGeom prst="rect">
+            <a:avLst/>
+          </a:prstGeom>
+          <a:noFill/>
+        </p:spPr>
+        <p:txBody>
+          <a:bodyPr wrap="square">
+            <a:spAutoFit/>
+          </a:bodyPr>
+          <a:lstStyle/>
+          <a:p>
+            <a:pPr algn="l">
+              <a:defRPr sz="1000" b="0">
+                <a:solidFill>
+                  <a:srgbClr val="0F172A"/>
+                </a:solidFill>
+              </a:defRPr>
+            </a:pPr>
+            <a:r>
+              <a:t>UM6P Instruments</a:t>
+            </a:r>
+          </a:p>
+        </p:txBody>
+      </p:sp>
+      <p:sp>
+        <p:nvSpPr>
+          <p:cNvPr id="41" name="Rounded Rectangle 40"/>
+          <p:cNvSpPr/>
+          <p:nvPr/>
+        </p:nvSpPr>
+        <p:spPr>
+          <a:xfrm>
+            <a:off x="548640" y="4800600"/>
+            <a:ext cx="109728" cy="109728"/>
+          </a:xfrm>
+          <a:prstGeom prst="roundRect">
+            <a:avLst>
+              <a:gd name="adj" fmla="val 50000"/>
+            </a:avLst>
+          </a:prstGeom>
+          <a:solidFill>
+            <a:srgbClr val="3B82F6"/>
+          </a:solidFill>
+          <a:ln>
+            <a:noFill/>
+          </a:ln>
+        </p:spPr>
+        <p:style>
+          <a:lnRef idx="1">
+            <a:schemeClr val="accent1"/>
+          </a:lnRef>
+          <a:fillRef idx="3">
+            <a:schemeClr val="accent1"/>
+          </a:fillRef>
+          <a:effectRef idx="2">
+            <a:schemeClr val="accent1"/>
+          </a:effectRef>
+          <a:fontRef idx="minor">
+            <a:schemeClr val="lt1"/>
+          </a:fontRef>
+        </p:style>
+        <p:txBody>
+          <a:bodyPr rtlCol="0" anchor="ctr"/>
+          <a:lstStyle/>
+          <a:p>
+            <a:pPr algn="ctr"/>
+          </a:p>
+        </p:txBody>
+      </p:sp>
+      <p:sp>
+        <p:nvSpPr>
+          <p:cNvPr id="42" name="TextBox 41"/>
+          <p:cNvSpPr txBox="1"/>
+          <p:nvPr/>
+        </p:nvSpPr>
+        <p:spPr>
+          <a:xfrm>
+            <a:off x="731520" y="4754880"/>
+            <a:ext cx="3566160" cy="228600"/>
+          </a:xfrm>
+          <a:prstGeom prst="rect">
+            <a:avLst/>
+          </a:prstGeom>
+          <a:noFill/>
+        </p:spPr>
+        <p:txBody>
+          <a:bodyPr wrap="square">
+            <a:spAutoFit/>
+          </a:bodyPr>
+          <a:lstStyle/>
+          <a:p>
+            <a:pPr algn="l">
+              <a:defRPr sz="1000" b="0">
+                <a:solidFill>
+                  <a:srgbClr val="0F172A"/>
+                </a:solidFill>
+              </a:defRPr>
+            </a:pPr>
+            <a:r>
+              <a:t>GeoHeritage</a:t>
+            </a:r>
+          </a:p>
+        </p:txBody>
+      </p:sp>
+      <p:sp>
+        <p:nvSpPr>
+          <p:cNvPr id="43" name="Rounded Rectangle 42"/>
+          <p:cNvSpPr/>
+          <p:nvPr/>
+        </p:nvSpPr>
+        <p:spPr>
+          <a:xfrm>
+            <a:off x="548640" y="5074920"/>
+            <a:ext cx="109728" cy="109728"/>
+          </a:xfrm>
+          <a:prstGeom prst="roundRect">
+            <a:avLst>
+              <a:gd name="adj" fmla="val 50000"/>
+            </a:avLst>
+          </a:prstGeom>
+          <a:solidFill>
+            <a:srgbClr val="3B82F6"/>
+          </a:solidFill>
+          <a:ln>
+            <a:noFill/>
+          </a:ln>
+        </p:spPr>
+        <p:style>
+          <a:lnRef idx="1">
+            <a:schemeClr val="accent1"/>
+          </a:lnRef>
+          <a:fillRef idx="3">
+            <a:schemeClr val="accent1"/>
+          </a:fillRef>
+          <a:effectRef idx="2">
+            <a:schemeClr val="accent1"/>
+          </a:effectRef>
+          <a:fontRef idx="minor">
+            <a:schemeClr val="lt1"/>
+          </a:fontRef>
+        </p:style>
+        <p:txBody>
+          <a:bodyPr rtlCol="0" anchor="ctr"/>
+          <a:lstStyle/>
+          <a:p>
+            <a:pPr algn="ctr"/>
+          </a:p>
+        </p:txBody>
+      </p:sp>
+      <p:sp>
+        <p:nvSpPr>
+          <p:cNvPr id="44" name="TextBox 43"/>
+          <p:cNvSpPr txBox="1"/>
+          <p:nvPr/>
+        </p:nvSpPr>
+        <p:spPr>
+          <a:xfrm>
+            <a:off x="731520" y="5029200"/>
+            <a:ext cx="3566160" cy="228600"/>
+          </a:xfrm>
+          <a:prstGeom prst="rect">
+            <a:avLst/>
+          </a:prstGeom>
+          <a:noFill/>
+        </p:spPr>
+        <p:txBody>
+          <a:bodyPr wrap="square">
+            <a:spAutoFit/>
+          </a:bodyPr>
+          <a:lstStyle/>
+          <a:p>
+            <a:pPr algn="l">
+              <a:defRPr sz="1000" b="0">
+                <a:solidFill>
+                  <a:srgbClr val="0F172A"/>
+                </a:solidFill>
+              </a:defRPr>
+            </a:pPr>
+            <a:r>
+              <a:t>G-ReLib</a:t>
+            </a:r>
+          </a:p>
+        </p:txBody>
+      </p:sp>
+      <p:sp>
+        <p:nvSpPr>
+          <p:cNvPr id="45" name="Rounded Rectangle 44"/>
+          <p:cNvSpPr/>
+          <p:nvPr/>
+        </p:nvSpPr>
+        <p:spPr>
+          <a:xfrm>
+            <a:off x="4663440" y="3794760"/>
+            <a:ext cx="4114800" cy="2286000"/>
+          </a:xfrm>
+          <a:prstGeom prst="roundRect">
+            <a:avLst>
+              <a:gd name="adj" fmla="val 5000"/>
+            </a:avLst>
+          </a:prstGeom>
+          <a:solidFill>
+            <a:srgbClr val="FFFFFF"/>
+          </a:solidFill>
+          <a:ln>
+            <a:noFill/>
+          </a:ln>
+        </p:spPr>
+        <p:style>
+          <a:lnRef idx="1">
+            <a:schemeClr val="accent1"/>
+          </a:lnRef>
+          <a:fillRef idx="3">
+            <a:schemeClr val="accent1"/>
+          </a:fillRef>
+          <a:effectRef idx="2">
+            <a:schemeClr val="accent1"/>
+          </a:effectRef>
+          <a:fontRef idx="minor">
+            <a:schemeClr val="lt1"/>
+          </a:fontRef>
+        </p:style>
+        <p:txBody>
+          <a:bodyPr rtlCol="0" anchor="ctr"/>
+          <a:lstStyle/>
+          <a:p>
+            <a:pPr algn="ctr"/>
+          </a:p>
+        </p:txBody>
+      </p:sp>
+      <p:sp>
+        <p:nvSpPr>
+          <p:cNvPr id="46" name="Rectangle 45"/>
+          <p:cNvSpPr/>
+          <p:nvPr/>
+        </p:nvSpPr>
+        <p:spPr>
+          <a:xfrm>
+            <a:off x="4663440" y="3794760"/>
+            <a:ext cx="4114800" cy="63500"/>
+          </a:xfrm>
+          <a:prstGeom prst="rect">
+            <a:avLst/>
+          </a:prstGeom>
+          <a:solidFill>
+            <a:srgbClr val="F97316"/>
+          </a:solidFill>
+          <a:ln>
+            <a:noFill/>
+          </a:ln>
+        </p:spPr>
+        <p:style>
+          <a:lnRef idx="1">
+            <a:schemeClr val="accent1"/>
+          </a:lnRef>
+          <a:fillRef idx="3">
+            <a:schemeClr val="accent1"/>
+          </a:fillRef>
+          <a:effectRef idx="2">
+            <a:schemeClr val="accent1"/>
+          </a:effectRef>
+          <a:fontRef idx="minor">
+            <a:schemeClr val="lt1"/>
+          </a:fontRef>
+        </p:style>
+        <p:txBody>
+          <a:bodyPr rtlCol="0" anchor="ctr"/>
+          <a:lstStyle/>
+          <a:p>
+            <a:pPr algn="ctr"/>
+          </a:p>
+        </p:txBody>
+      </p:sp>
+      <p:sp>
+        <p:nvSpPr>
+          <p:cNvPr id="47" name="TextBox 46"/>
+          <p:cNvSpPr txBox="1"/>
+          <p:nvPr/>
+        </p:nvSpPr>
+        <p:spPr>
+          <a:xfrm>
+            <a:off x="4800600" y="3931920"/>
+            <a:ext cx="3840480" cy="320040"/>
+          </a:xfrm>
+          <a:prstGeom prst="rect">
+            <a:avLst/>
+          </a:prstGeom>
+          <a:noFill/>
+        </p:spPr>
+        <p:txBody>
+          <a:bodyPr wrap="square">
+            <a:spAutoFit/>
+          </a:bodyPr>
+          <a:lstStyle/>
+          <a:p>
+            <a:pPr algn="l">
+              <a:defRPr sz="1400" b="1">
+                <a:solidFill>
+                  <a:srgbClr val="0F172A"/>
+                </a:solidFill>
+              </a:defRPr>
+            </a:pPr>
+            <a:r>
+              <a:t>Mohammed Damiri</a:t>
+            </a:r>
+          </a:p>
+        </p:txBody>
+      </p:sp>
+      <p:sp>
+        <p:nvSpPr>
+          <p:cNvPr id="48" name="TextBox 47"/>
+          <p:cNvSpPr txBox="1"/>
+          <p:nvPr/>
+        </p:nvSpPr>
+        <p:spPr>
+          <a:xfrm>
+            <a:off x="4800600" y="4206240"/>
+            <a:ext cx="3840480" cy="182880"/>
+          </a:xfrm>
+          <a:prstGeom prst="rect">
+            <a:avLst/>
+          </a:prstGeom>
+          <a:noFill/>
+        </p:spPr>
+        <p:txBody>
+          <a:bodyPr wrap="square">
+            <a:spAutoFit/>
+          </a:bodyPr>
+          <a:lstStyle/>
+          <a:p>
+            <a:pPr algn="l">
+              <a:defRPr sz="800" b="0">
+                <a:solidFill>
+                  <a:srgbClr val="64748B"/>
+                </a:solidFill>
+              </a:defRPr>
+            </a:pPr>
+            <a:r>
+              <a:t>Mentor  —  2 startups assignées</a:t>
+            </a:r>
+          </a:p>
+        </p:txBody>
+      </p:sp>
+      <p:sp>
+        <p:nvSpPr>
+          <p:cNvPr id="49" name="Rounded Rectangle 48"/>
+          <p:cNvSpPr/>
+          <p:nvPr/>
+        </p:nvSpPr>
+        <p:spPr>
+          <a:xfrm>
+            <a:off x="4846320" y="4526280"/>
+            <a:ext cx="109728" cy="109728"/>
+          </a:xfrm>
+          <a:prstGeom prst="roundRect">
+            <a:avLst>
+              <a:gd name="adj" fmla="val 50000"/>
+            </a:avLst>
+          </a:prstGeom>
+          <a:solidFill>
+            <a:srgbClr val="F97316"/>
+          </a:solidFill>
+          <a:ln>
+            <a:noFill/>
+          </a:ln>
+        </p:spPr>
+        <p:style>
+          <a:lnRef idx="1">
+            <a:schemeClr val="accent1"/>
+          </a:lnRef>
+          <a:fillRef idx="3">
+            <a:schemeClr val="accent1"/>
+          </a:fillRef>
+          <a:effectRef idx="2">
+            <a:schemeClr val="accent1"/>
+          </a:effectRef>
+          <a:fontRef idx="minor">
+            <a:schemeClr val="lt1"/>
+          </a:fontRef>
+        </p:style>
+        <p:txBody>
+          <a:bodyPr rtlCol="0" anchor="ctr"/>
+          <a:lstStyle/>
+          <a:p>
+            <a:pPr algn="ctr"/>
+          </a:p>
+        </p:txBody>
+      </p:sp>
+      <p:sp>
+        <p:nvSpPr>
+          <p:cNvPr id="50" name="TextBox 49"/>
+          <p:cNvSpPr txBox="1"/>
+          <p:nvPr/>
+        </p:nvSpPr>
+        <p:spPr>
+          <a:xfrm>
+            <a:off x="5029200" y="4480560"/>
+            <a:ext cx="3566160" cy="228600"/>
+          </a:xfrm>
+          <a:prstGeom prst="rect">
+            <a:avLst/>
+          </a:prstGeom>
+          <a:noFill/>
+        </p:spPr>
+        <p:txBody>
+          <a:bodyPr wrap="square">
+            <a:spAutoFit/>
+          </a:bodyPr>
+          <a:lstStyle/>
+          <a:p>
+            <a:pPr algn="l">
+              <a:defRPr sz="1000" b="0">
+                <a:solidFill>
+                  <a:srgbClr val="0F172A"/>
+                </a:solidFill>
+              </a:defRPr>
+            </a:pPr>
+            <a:r>
+              <a:t>DECAP</a:t>
+            </a:r>
+          </a:p>
+        </p:txBody>
+      </p:sp>
+      <p:sp>
+        <p:nvSpPr>
+          <p:cNvPr id="51" name="Rounded Rectangle 50"/>
+          <p:cNvSpPr/>
+          <p:nvPr/>
+        </p:nvSpPr>
+        <p:spPr>
+          <a:xfrm>
+            <a:off x="4846320" y="4800600"/>
+            <a:ext cx="109728" cy="109728"/>
+          </a:xfrm>
+          <a:prstGeom prst="roundRect">
+            <a:avLst>
+              <a:gd name="adj" fmla="val 50000"/>
+            </a:avLst>
+          </a:prstGeom>
+          <a:solidFill>
+            <a:srgbClr val="F97316"/>
+          </a:solidFill>
+          <a:ln>
+            <a:noFill/>
+          </a:ln>
+        </p:spPr>
+        <p:style>
+          <a:lnRef idx="1">
+            <a:schemeClr val="accent1"/>
+          </a:lnRef>
+          <a:fillRef idx="3">
+            <a:schemeClr val="accent1"/>
+          </a:fillRef>
+          <a:effectRef idx="2">
+            <a:schemeClr val="accent1"/>
+          </a:effectRef>
+          <a:fontRef idx="minor">
+            <a:schemeClr val="lt1"/>
+          </a:fontRef>
+        </p:style>
+        <p:txBody>
+          <a:bodyPr rtlCol="0" anchor="ctr"/>
+          <a:lstStyle/>
+          <a:p>
+            <a:pPr algn="ctr"/>
+          </a:p>
+        </p:txBody>
+      </p:sp>
+      <p:sp>
+        <p:nvSpPr>
+          <p:cNvPr id="52" name="TextBox 51"/>
+          <p:cNvSpPr txBox="1"/>
+          <p:nvPr/>
+        </p:nvSpPr>
+        <p:spPr>
+          <a:xfrm>
+            <a:off x="5029200" y="4754880"/>
+            <a:ext cx="3566160" cy="228600"/>
+          </a:xfrm>
+          <a:prstGeom prst="rect">
+            <a:avLst/>
+          </a:prstGeom>
+          <a:noFill/>
+        </p:spPr>
+        <p:txBody>
+          <a:bodyPr wrap="square">
+            <a:spAutoFit/>
+          </a:bodyPr>
+          <a:lstStyle/>
+          <a:p>
+            <a:pPr algn="l">
+              <a:defRPr sz="1000" b="0">
+                <a:solidFill>
+                  <a:srgbClr val="0F172A"/>
+                </a:solidFill>
+              </a:defRPr>
+            </a:pPr>
+            <a:r>
+              <a:t>GreenFlow</a:t>
+            </a:r>
+          </a:p>
+        </p:txBody>
+      </p:sp>
+      <p:sp>
+        <p:nvSpPr>
+          <p:cNvPr id="53" name="TextBox 52"/>
+          <p:cNvSpPr txBox="1"/>
+          <p:nvPr/>
+        </p:nvSpPr>
+        <p:spPr>
+          <a:xfrm>
+            <a:off x="365760" y="6263640"/>
+            <a:ext cx="8229600" cy="228600"/>
+          </a:xfrm>
+          <a:prstGeom prst="rect">
+            <a:avLst/>
+          </a:prstGeom>
+          <a:noFill/>
+        </p:spPr>
+        <p:txBody>
+          <a:bodyPr wrap="square">
+            <a:spAutoFit/>
+          </a:bodyPr>
+          <a:lstStyle/>
+          <a:p>
+            <a:pPr algn="ctr">
+              <a:defRPr sz="900" b="1">
+                <a:solidFill>
+                  <a:srgbClr val="475569"/>
+                </a:solidFill>
+              </a:defRPr>
+            </a:pPr>
+            <a:r>
+              <a:t>4 mentors  |  14 startups accompagnées  |  Ratio moyen : 3,5 startups / mentor</a:t>
+            </a:r>
+          </a:p>
+        </p:txBody>
+      </p:sp>
+      <p:sp>
+        <p:nvSpPr>
+          <p:cNvPr id="54" name="TextBox 53"/>
           <p:cNvSpPr txBox="1"/>
           <p:nvPr/>
         </p:nvSpPr>
@@ -15520,7 +18129,7 @@
       </p:sp>
       <p:sp>
         <p:nvSpPr>
-          <p:cNvPr id="22" name="TextBox 21"/>
+          <p:cNvPr id="55" name="TextBox 54"/>
           <p:cNvSpPr txBox="1"/>
           <p:nvPr/>
         </p:nvSpPr>
@@ -15548,7 +18157,7 @@
               </a:defRPr>
             </a:pPr>
             <a:r>
-              <a:t>Page 7/7  |  Rapport partenaires</a:t>
+              <a:t>Page 8/8  |  Rapport partenaires</a:t>
             </a:r>
           </a:p>
         </p:txBody>

</xml_diff>

<commit_message>
rapport J+8: mise à jour données 6-13 avril (GA + DB prod)
Cumuls 8 jours:
- Sessions: 2 665 (+224), Users: 1 855 (+155)
- Membres inscrits: 48 (+4), Confirmés: 22 (+5)
- Avec photo: 11, Avec password: 8
- Experts: 5 (vs 3), Messages: 10 (vs 9)
- Pages: Startups 3 067, Accueil 1 892, Join 1 010
- Géo: Maroc 1 440, France 151, USA 56, Canada 33
- Sources: Direct 1 378, Organic 1 063
- Ajout J8 (13 avr) dans la tendance visites: 224 sessions
- PDF et PPTX synchronisés

Co-Authored-By: Claude Opus 4.6 <noreply@anthropic.com>
</commit_message>
<xml_diff>
--- a/Rapport_J7_ThePulse_Partenaires.pptx
+++ b/Rapport_J7_ThePulse_Partenaires.pptx
@@ -3200,7 +3200,7 @@
               </a:defRPr>
             </a:pPr>
             <a:r>
-              <a:t>Rapport J+7</a:t>
+              <a:t>Rapport J+8</a:t>
             </a:r>
           </a:p>
         </p:txBody>
@@ -3348,7 +3348,7 @@
               </a:defRPr>
             </a:pPr>
             <a:r>
-              <a:t>Période : 6 - 12 avril 2026</a:t>
+              <a:t>Période : 6 - 13 avril 2026</a:t>
             </a:r>
           </a:p>
         </p:txBody>
@@ -3383,7 +3383,7 @@
               </a:defRPr>
             </a:pPr>
             <a:r>
-              <a:t>7 jours après le lancement officiel</a:t>
+              <a:t>8 jours après le lancement officiel</a:t>
             </a:r>
           </a:p>
         </p:txBody>
@@ -4080,7 +4080,7 @@
               </a:defRPr>
             </a:pPr>
             <a:r>
-              <a:t>The Pulse  |  J+7</a:t>
+              <a:t>The Pulse  |  J+8</a:t>
             </a:r>
           </a:p>
         </p:txBody>
@@ -6427,7 +6427,7 @@
               </a:defRPr>
             </a:pPr>
             <a:r>
-              <a:t>6 - 12 avril 2026</a:t>
+              <a:t>6 - 13 avril 2026</a:t>
             </a:r>
           </a:p>
         </p:txBody>
@@ -6585,7 +6585,7 @@
               </a:defRPr>
             </a:pPr>
             <a:r>
-              <a:t>2 441</a:t>
+              <a:t>2 665</a:t>
             </a:r>
           </a:p>
         </p:txBody>
@@ -6743,7 +6743,7 @@
               </a:defRPr>
             </a:pPr>
             <a:r>
-              <a:t>1 700</a:t>
+              <a:t>1 855</a:t>
             </a:r>
           </a:p>
         </p:txBody>
@@ -6901,7 +6901,7 @@
               </a:defRPr>
             </a:pPr>
             <a:r>
-              <a:t>1 600</a:t>
+              <a:t>1 748</a:t>
             </a:r>
           </a:p>
         </p:txBody>
@@ -7375,7 +7375,7 @@
               </a:defRPr>
             </a:pPr>
             <a:r>
-              <a:t>28 293</a:t>
+              <a:t>30 683</a:t>
             </a:r>
           </a:p>
         </p:txBody>
@@ -7480,7 +7480,7 @@
               </a:defRPr>
             </a:pPr>
             <a:r>
-              <a:t>Direct  —  1 282 (52,5%)</a:t>
+              <a:t>Direct  —  1 378 (51,7%)</a:t>
             </a:r>
           </a:p>
         </p:txBody>
@@ -7515,7 +7515,7 @@
               </a:defRPr>
             </a:pPr>
             <a:r>
-              <a:t>Recherche organique (Google)  —  967 (39,6%)</a:t>
+              <a:t>Recherche organique (Google)  —  1 063 (39,9%)</a:t>
             </a:r>
           </a:p>
         </p:txBody>
@@ -7550,7 +7550,7 @@
               </a:defRPr>
             </a:pPr>
             <a:r>
-              <a:t>Réseaux sociaux (LinkedIn)  —  111 (4,5%)</a:t>
+              <a:t>Réseaux sociaux (LinkedIn)  —  114 (4,3%)</a:t>
             </a:r>
           </a:p>
         </p:txBody>
@@ -7585,7 +7585,7 @@
               </a:defRPr>
             </a:pPr>
             <a:r>
-              <a:t>Referrals (Medias24, etc.)  —  57 (2,3%)</a:t>
+              <a:t>Referrals (Medias24, etc.)  —  63 (2,4%)</a:t>
             </a:r>
           </a:p>
         </p:txBody>
@@ -7620,7 +7620,7 @@
               </a:defRPr>
             </a:pPr>
             <a:r>
-              <a:t>Autres  —  24 (1,0%)</a:t>
+              <a:t>Autres  —  47 (1,8%)</a:t>
             </a:r>
           </a:p>
         </p:txBody>
@@ -7839,7 +7839,7 @@
                         </a:defRPr>
                       </a:pPr>
                       <a:r>
-                        <a:t>1 320</a:t>
+                        <a:t>1 440</a:t>
                       </a:r>
                     </a:p>
                   </a:txBody>
@@ -7862,7 +7862,7 @@
                         </a:defRPr>
                       </a:pPr>
                       <a:r>
-                        <a:t>79,9%</a:t>
+                        <a:t>77,6%</a:t>
                       </a:r>
                     </a:p>
                   </a:txBody>
@@ -7885,7 +7885,7 @@
                         </a:defRPr>
                       </a:pPr>
                       <a:r>
-                        <a:t>57,7%</a:t>
+                        <a:t>55,2%</a:t>
                       </a:r>
                     </a:p>
                   </a:txBody>
@@ -7908,7 +7908,7 @@
                         </a:defRPr>
                       </a:pPr>
                       <a:r>
-                        <a:t>2m 22s</a:t>
+                        <a:t>2m 18s</a:t>
                       </a:r>
                     </a:p>
                   </a:txBody>
@@ -7956,7 +7956,7 @@
                         </a:defRPr>
                       </a:pPr>
                       <a:r>
-                        <a:t>141</a:t>
+                        <a:t>151</a:t>
                       </a:r>
                     </a:p>
                   </a:txBody>
@@ -7979,7 +7979,7 @@
                         </a:defRPr>
                       </a:pPr>
                       <a:r>
-                        <a:t>8,5%</a:t>
+                        <a:t>8,1%</a:t>
                       </a:r>
                     </a:p>
                   </a:txBody>
@@ -8002,7 +8002,7 @@
                         </a:defRPr>
                       </a:pPr>
                       <a:r>
-                        <a:t>62,3%</a:t>
+                        <a:t>61,5%</a:t>
                       </a:r>
                     </a:p>
                   </a:txBody>
@@ -8025,7 +8025,7 @@
                         </a:defRPr>
                       </a:pPr>
                       <a:r>
-                        <a:t>1m 45s</a:t>
+                        <a:t>1m 42s</a:t>
                       </a:r>
                     </a:p>
                   </a:txBody>
@@ -8073,7 +8073,7 @@
                         </a:defRPr>
                       </a:pPr>
                       <a:r>
-                        <a:t>52</a:t>
+                        <a:t>56</a:t>
                       </a:r>
                     </a:p>
                   </a:txBody>
@@ -8096,7 +8096,7 @@
                         </a:defRPr>
                       </a:pPr>
                       <a:r>
-                        <a:t>3,2%</a:t>
+                        <a:t>3,0%</a:t>
                       </a:r>
                     </a:p>
                   </a:txBody>
@@ -8119,7 +8119,7 @@
                         </a:defRPr>
                       </a:pPr>
                       <a:r>
-                        <a:t>36,5%</a:t>
+                        <a:t>35,8%</a:t>
                       </a:r>
                     </a:p>
                   </a:txBody>
@@ -8142,7 +8142,7 @@
                         </a:defRPr>
                       </a:pPr>
                       <a:r>
-                        <a:t>38s</a:t>
+                        <a:t>36s</a:t>
                       </a:r>
                     </a:p>
                   </a:txBody>
@@ -8190,7 +8190,7 @@
                         </a:defRPr>
                       </a:pPr>
                       <a:r>
-                        <a:t>29</a:t>
+                        <a:t>33</a:t>
                       </a:r>
                     </a:p>
                   </a:txBody>
@@ -8236,7 +8236,7 @@
                         </a:defRPr>
                       </a:pPr>
                       <a:r>
-                        <a:t>60,6%</a:t>
+                        <a:t>59,4%</a:t>
                       </a:r>
                     </a:p>
                   </a:txBody>
@@ -8259,7 +8259,7 @@
                         </a:defRPr>
                       </a:pPr>
                       <a:r>
-                        <a:t>1m 06s</a:t>
+                        <a:t>1m 04s</a:t>
                       </a:r>
                     </a:p>
                   </a:txBody>
@@ -8307,7 +8307,7 @@
                         </a:defRPr>
                       </a:pPr>
                       <a:r>
-                        <a:t>15</a:t>
+                        <a:t>19</a:t>
                       </a:r>
                     </a:p>
                   </a:txBody>
@@ -8330,7 +8330,7 @@
                         </a:defRPr>
                       </a:pPr>
                       <a:r>
-                        <a:t>0,9%</a:t>
+                        <a:t>1,0%</a:t>
                       </a:r>
                     </a:p>
                   </a:txBody>
@@ -8353,7 +8353,7 @@
                         </a:defRPr>
                       </a:pPr>
                       <a:r>
-                        <a:t>78,3%</a:t>
+                        <a:t>76,1%</a:t>
                       </a:r>
                     </a:p>
                   </a:txBody>
@@ -8376,7 +8376,7 @@
                         </a:defRPr>
                       </a:pPr>
                       <a:r>
-                        <a:t>3m 17s</a:t>
+                        <a:t>3m 10s</a:t>
                       </a:r>
                     </a:p>
                   </a:txBody>
@@ -8447,7 +8447,7 @@
                         </a:defRPr>
                       </a:pPr>
                       <a:r>
-                        <a:t>0,9%</a:t>
+                        <a:t>0,8%</a:t>
                       </a:r>
                     </a:p>
                   </a:txBody>
@@ -8564,7 +8564,7 @@
                         </a:defRPr>
                       </a:pPr>
                       <a:r>
-                        <a:t>0,7%</a:t>
+                        <a:t>0,6%</a:t>
                       </a:r>
                     </a:p>
                   </a:txBody>
@@ -8635,7 +8635,7 @@
                         </a:defRPr>
                       </a:pPr>
                       <a:r>
-                        <a:t>Belgique</a:t>
+                        <a:t>Espagne</a:t>
                       </a:r>
                     </a:p>
                   </a:txBody>
@@ -8658,7 +8658,7 @@
                         </a:defRPr>
                       </a:pPr>
                       <a:r>
-                        <a:t>9</a:t>
+                        <a:t>3</a:t>
                       </a:r>
                     </a:p>
                   </a:txBody>
@@ -8681,7 +8681,7 @@
                         </a:defRPr>
                       </a:pPr>
                       <a:r>
-                        <a:t>0,5%</a:t>
+                        <a:t>0,2%</a:t>
                       </a:r>
                     </a:p>
                   </a:txBody>
@@ -8704,7 +8704,7 @@
                         </a:defRPr>
                       </a:pPr>
                       <a:r>
-                        <a:t>58,3%</a:t>
+                        <a:t>50,0%</a:t>
                       </a:r>
                     </a:p>
                   </a:txBody>
@@ -8727,7 +8727,7 @@
                         </a:defRPr>
                       </a:pPr>
                       <a:r>
-                        <a:t>29s</a:t>
+                        <a:t>45s</a:t>
                       </a:r>
                     </a:p>
                   </a:txBody>
@@ -8772,7 +8772,7 @@
               </a:defRPr>
             </a:pPr>
             <a:r>
-              <a:t>Source : Google Analytics (G-9TTHWMF6L0) - Période du 6 au 12 avril 2026</a:t>
+              <a:t>Source : Google Analytics (G-9TTHWMF6L0) - Période du 6 au 13 avril 2026</a:t>
             </a:r>
           </a:p>
         </p:txBody>
@@ -8978,7 +8978,7 @@
               </a:defRPr>
             </a:pPr>
             <a:r>
-              <a:t>6 - 12 avril 2026</a:t>
+              <a:t>6 - 13 avril 2026</a:t>
             </a:r>
           </a:p>
         </p:txBody>
@@ -9197,7 +9197,7 @@
                         </a:defRPr>
                       </a:pPr>
                       <a:r>
-                        <a:t>2 800</a:t>
+                        <a:t>3 067</a:t>
                       </a:r>
                     </a:p>
                   </a:txBody>
@@ -9220,7 +9220,7 @@
                         </a:defRPr>
                       </a:pPr>
                       <a:r>
-                        <a:t>623</a:t>
+                        <a:t>690</a:t>
                       </a:r>
                     </a:p>
                   </a:txBody>
@@ -9243,7 +9243,7 @@
                         </a:defRPr>
                       </a:pPr>
                       <a:r>
-                        <a:t>19,1%</a:t>
+                        <a:t>18,5%</a:t>
                       </a:r>
                     </a:p>
                   </a:txBody>
@@ -9314,7 +9314,7 @@
                         </a:defRPr>
                       </a:pPr>
                       <a:r>
-                        <a:t>1 800</a:t>
+                        <a:t>1 892</a:t>
                       </a:r>
                     </a:p>
                   </a:txBody>
@@ -9337,7 +9337,7 @@
                         </a:defRPr>
                       </a:pPr>
                       <a:r>
-                        <a:t>1 200</a:t>
+                        <a:t>1 310</a:t>
                       </a:r>
                     </a:p>
                   </a:txBody>
@@ -9360,7 +9360,7 @@
                         </a:defRPr>
                       </a:pPr>
                       <a:r>
-                        <a:t>36,5%</a:t>
+                        <a:t>35,2%</a:t>
                       </a:r>
                     </a:p>
                   </a:txBody>
@@ -9431,7 +9431,7 @@
                         </a:defRPr>
                       </a:pPr>
                       <a:r>
-                        <a:t>952</a:t>
+                        <a:t>1 010</a:t>
                       </a:r>
                     </a:p>
                   </a:txBody>
@@ -9454,7 +9454,7 @@
                         </a:defRPr>
                       </a:pPr>
                       <a:r>
-                        <a:t>683</a:t>
+                        <a:t>725</a:t>
                       </a:r>
                     </a:p>
                   </a:txBody>
@@ -9477,7 +9477,7 @@
                         </a:defRPr>
                       </a:pPr>
                       <a:r>
-                        <a:t>18,8%</a:t>
+                        <a:t>17,9%</a:t>
                       </a:r>
                     </a:p>
                   </a:txBody>
@@ -9548,7 +9548,7 @@
                         </a:defRPr>
                       </a:pPr>
                       <a:r>
-                        <a:t>536</a:t>
+                        <a:t>576</a:t>
                       </a:r>
                     </a:p>
                   </a:txBody>
@@ -9571,7 +9571,7 @@
                         </a:defRPr>
                       </a:pPr>
                       <a:r>
-                        <a:t>195</a:t>
+                        <a:t>215</a:t>
                       </a:r>
                     </a:p>
                   </a:txBody>
@@ -9594,7 +9594,7 @@
                         </a:defRPr>
                       </a:pPr>
                       <a:r>
-                        <a:t>11,5%</a:t>
+                        <a:t>11,0%</a:t>
                       </a:r>
                     </a:p>
                   </a:txBody>
@@ -9665,7 +9665,7 @@
                         </a:defRPr>
                       </a:pPr>
                       <a:r>
-                        <a:t>381</a:t>
+                        <a:t>403</a:t>
                       </a:r>
                     </a:p>
                   </a:txBody>
@@ -9688,7 +9688,7 @@
                         </a:defRPr>
                       </a:pPr>
                       <a:r>
-                        <a:t>164</a:t>
+                        <a:t>176</a:t>
                       </a:r>
                     </a:p>
                   </a:txBody>
@@ -9711,7 +9711,7 @@
                         </a:defRPr>
                       </a:pPr>
                       <a:r>
-                        <a:t>10,4%</a:t>
+                        <a:t>10,1%</a:t>
                       </a:r>
                     </a:p>
                   </a:txBody>
@@ -9759,7 +9759,7 @@
                         </a:defRPr>
                       </a:pPr>
                       <a:r>
-                        <a:t>Ressources</a:t>
+                        <a:t>Se connecter</a:t>
                       </a:r>
                     </a:p>
                   </a:txBody>
@@ -9782,7 +9782,7 @@
                         </a:defRPr>
                       </a:pPr>
                       <a:r>
-                        <a:t>282</a:t>
+                        <a:t>302</a:t>
                       </a:r>
                     </a:p>
                   </a:txBody>
@@ -9805,7 +9805,7 @@
                         </a:defRPr>
                       </a:pPr>
                       <a:r>
-                        <a:t>216</a:t>
+                        <a:t>240</a:t>
                       </a:r>
                     </a:p>
                   </a:txBody>
@@ -9828,7 +9828,7 @@
                         </a:defRPr>
                       </a:pPr>
                       <a:r>
-                        <a:t>14,2%</a:t>
+                        <a:t>12,8%</a:t>
                       </a:r>
                     </a:p>
                   </a:txBody>
@@ -9876,7 +9876,7 @@
                         </a:defRPr>
                       </a:pPr>
                       <a:r>
-                        <a:t>Formulaire inscription startup</a:t>
+                        <a:t>Co-Fondateurs</a:t>
                       </a:r>
                     </a:p>
                   </a:txBody>
@@ -9899,7 +9899,7 @@
                         </a:defRPr>
                       </a:pPr>
                       <a:r>
-                        <a:t>246</a:t>
+                        <a:t>282</a:t>
                       </a:r>
                     </a:p>
                   </a:txBody>
@@ -9922,7 +9922,7 @@
                         </a:defRPr>
                       </a:pPr>
                       <a:r>
-                        <a:t>210</a:t>
+                        <a:t>195</a:t>
                       </a:r>
                     </a:p>
                   </a:txBody>
@@ -9945,7 +9945,7 @@
                         </a:defRPr>
                       </a:pPr>
                       <a:r>
-                        <a:t>6,7%</a:t>
+                        <a:t>9,2%</a:t>
                       </a:r>
                     </a:p>
                   </a:txBody>
@@ -10048,7 +10048,7 @@
               </a:defRPr>
             </a:pPr>
             <a:r>
-              <a:t>Tendance des visites (J1 → J7)</a:t>
+              <a:t>Tendance des visites (J1 → J8)</a:t>
             </a:r>
           </a:p>
         </p:txBody>
@@ -10866,6 +10866,121 @@
         </p:nvSpPr>
         <p:spPr>
           <a:xfrm>
+            <a:off x="457200" y="5888736"/>
+            <a:ext cx="1188720" cy="228600"/>
+          </a:xfrm>
+          <a:prstGeom prst="rect">
+            <a:avLst/>
+          </a:prstGeom>
+          <a:noFill/>
+        </p:spPr>
+        <p:txBody>
+          <a:bodyPr wrap="square">
+            <a:spAutoFit/>
+          </a:bodyPr>
+          <a:lstStyle/>
+          <a:p>
+            <a:pPr algn="l">
+              <a:defRPr sz="800" b="0">
+                <a:solidFill>
+                  <a:srgbClr val="0F172A"/>
+                </a:solidFill>
+              </a:defRPr>
+            </a:pPr>
+            <a:r>
+              <a:t>J8 (13 avr)</a:t>
+            </a:r>
+          </a:p>
+        </p:txBody>
+      </p:sp>
+      <p:sp>
+        <p:nvSpPr>
+          <p:cNvPr id="33" name="Rounded Rectangle 32"/>
+          <p:cNvSpPr/>
+          <p:nvPr/>
+        </p:nvSpPr>
+        <p:spPr>
+          <a:xfrm>
+            <a:off x="1691640" y="5907024"/>
+            <a:ext cx="1969476" cy="182880"/>
+          </a:xfrm>
+          <a:prstGeom prst="roundRect">
+            <a:avLst>
+              <a:gd name="adj" fmla="val 15000"/>
+            </a:avLst>
+          </a:prstGeom>
+          <a:solidFill>
+            <a:srgbClr val="64748B"/>
+          </a:solidFill>
+          <a:ln>
+            <a:noFill/>
+          </a:ln>
+        </p:spPr>
+        <p:style>
+          <a:lnRef idx="1">
+            <a:schemeClr val="accent1"/>
+          </a:lnRef>
+          <a:fillRef idx="3">
+            <a:schemeClr val="accent1"/>
+          </a:fillRef>
+          <a:effectRef idx="2">
+            <a:schemeClr val="accent1"/>
+          </a:effectRef>
+          <a:fontRef idx="minor">
+            <a:schemeClr val="lt1"/>
+          </a:fontRef>
+        </p:style>
+        <p:txBody>
+          <a:bodyPr rtlCol="0" anchor="ctr"/>
+          <a:lstStyle/>
+          <a:p>
+            <a:pPr algn="ctr"/>
+          </a:p>
+        </p:txBody>
+      </p:sp>
+      <p:sp>
+        <p:nvSpPr>
+          <p:cNvPr id="34" name="TextBox 33"/>
+          <p:cNvSpPr txBox="1"/>
+          <p:nvPr/>
+        </p:nvSpPr>
+        <p:spPr>
+          <a:xfrm>
+            <a:off x="3752556" y="5888736"/>
+            <a:ext cx="731520" cy="228600"/>
+          </a:xfrm>
+          <a:prstGeom prst="rect">
+            <a:avLst/>
+          </a:prstGeom>
+          <a:noFill/>
+        </p:spPr>
+        <p:txBody>
+          <a:bodyPr wrap="square">
+            <a:spAutoFit/>
+          </a:bodyPr>
+          <a:lstStyle/>
+          <a:p>
+            <a:pPr algn="l">
+              <a:defRPr sz="700" b="1">
+                <a:solidFill>
+                  <a:srgbClr val="0F172A"/>
+                </a:solidFill>
+              </a:defRPr>
+            </a:pPr>
+            <a:r>
+              <a:t>224 sess.</a:t>
+            </a:r>
+          </a:p>
+        </p:txBody>
+      </p:sp>
+      <p:sp>
+        <p:nvSpPr>
+          <p:cNvPr id="35" name="TextBox 34"/>
+          <p:cNvSpPr txBox="1"/>
+          <p:nvPr/>
+        </p:nvSpPr>
+        <p:spPr>
+          <a:xfrm>
             <a:off x="365760" y="5943600"/>
             <a:ext cx="8229600" cy="182880"/>
           </a:xfrm>
@@ -10895,7 +11010,7 @@
       </p:sp>
       <p:sp>
         <p:nvSpPr>
-          <p:cNvPr id="33" name="Rounded Rectangle 32"/>
+          <p:cNvPr id="36" name="Rounded Rectangle 35"/>
           <p:cNvSpPr/>
           <p:nvPr/>
         </p:nvSpPr>
@@ -10940,7 +11055,7 @@
       </p:sp>
       <p:sp>
         <p:nvSpPr>
-          <p:cNvPr id="34" name="Rectangle 33"/>
+          <p:cNvPr id="37" name="Rectangle 36"/>
           <p:cNvSpPr/>
           <p:nvPr/>
         </p:nvSpPr>
@@ -10983,7 +11098,7 @@
       </p:sp>
       <p:sp>
         <p:nvSpPr>
-          <p:cNvPr id="35" name="TextBox 34"/>
+          <p:cNvPr id="38" name="TextBox 37"/>
           <p:cNvSpPr txBox="1"/>
           <p:nvPr/>
         </p:nvSpPr>
@@ -11018,7 +11133,7 @@
       </p:sp>
       <p:sp>
         <p:nvSpPr>
-          <p:cNvPr id="36" name="TextBox 35"/>
+          <p:cNvPr id="39" name="TextBox 38"/>
           <p:cNvSpPr txBox="1"/>
           <p:nvPr/>
         </p:nvSpPr>
@@ -11046,7 +11161,7 @@
               </a:defRPr>
             </a:pPr>
             <a:r>
-              <a:t>Taux de rebond moyen de 16,6% vs 40-60% pour un SaaS B2B — les visiteurs explorent activement la plateforme. 44 inscriptions en 7 jours avec un pic à J4.</a:t>
+              <a:t>Taux de rebond moyen de 16,6% vs 40-60% pour un SaaS B2B — les visiteurs explorent activement la plateforme. 44 inscriptions en 8 jours avec un pic à J4.</a:t>
             </a:r>
           </a:p>
         </p:txBody>
@@ -11252,7 +11367,7 @@
               </a:defRPr>
             </a:pPr>
             <a:r>
-              <a:t>Au 12 avril 2026</a:t>
+              <a:t>Au 13 avril 2026</a:t>
             </a:r>
           </a:p>
         </p:txBody>
@@ -11410,7 +11525,7 @@
               </a:defRPr>
             </a:pPr>
             <a:r>
-              <a:t>44</a:t>
+              <a:t>48</a:t>
             </a:r>
           </a:p>
         </p:txBody>
@@ -11568,7 +11683,7 @@
               </a:defRPr>
             </a:pPr>
             <a:r>
-              <a:t>17</a:t>
+              <a:t>22</a:t>
             </a:r>
           </a:p>
         </p:txBody>
@@ -11726,7 +11841,7 @@
               </a:defRPr>
             </a:pPr>
             <a:r>
-              <a:t>27</a:t>
+              <a:t>26</a:t>
             </a:r>
           </a:p>
         </p:txBody>
@@ -11884,7 +11999,7 @@
               </a:defRPr>
             </a:pPr>
             <a:r>
-              <a:t>9</a:t>
+              <a:t>11</a:t>
             </a:r>
           </a:p>
         </p:txBody>
@@ -11989,7 +12104,7 @@
               </a:defRPr>
             </a:pPr>
             <a:r>
-              <a:t>Entrepreneurs  —  33 (75,0%)</a:t>
+              <a:t>Entrepreneurs  —  35 (72,9%)</a:t>
             </a:r>
           </a:p>
         </p:txBody>
@@ -12024,7 +12139,7 @@
               </a:defRPr>
             </a:pPr>
             <a:r>
-              <a:t>Investisseurs  —  5 (11,4%)</a:t>
+              <a:t>Investisseurs  —  5 (10,4%)</a:t>
             </a:r>
           </a:p>
         </p:txBody>
@@ -12059,7 +12174,7 @@
               </a:defRPr>
             </a:pPr>
             <a:r>
-              <a:t>Experts  —  3 (6,8%)</a:t>
+              <a:t>Experts  —  5 (10,4%)</a:t>
             </a:r>
           </a:p>
         </p:txBody>
@@ -12094,7 +12209,7 @@
               </a:defRPr>
             </a:pPr>
             <a:r>
-              <a:t>Programmes / Incubateurs  —  3 (6,8%)</a:t>
+              <a:t>Programmes / Incubateurs  —  3 (6,3%)</a:t>
             </a:r>
           </a:p>
         </p:txBody>
@@ -12387,6 +12502,41 @@
         </p:nvSpPr>
         <p:spPr>
           <a:xfrm>
+            <a:off x="457200" y="4709160"/>
+            <a:ext cx="3657600" cy="182880"/>
+          </a:xfrm>
+          <a:prstGeom prst="rect">
+            <a:avLst/>
+          </a:prstGeom>
+          <a:noFill/>
+        </p:spPr>
+        <p:txBody>
+          <a:bodyPr wrap="square">
+            <a:spAutoFit/>
+          </a:bodyPr>
+          <a:lstStyle/>
+          <a:p>
+            <a:pPr algn="l">
+              <a:defRPr sz="900" b="0">
+                <a:solidFill>
+                  <a:srgbClr val="0F172A"/>
+                </a:solidFill>
+              </a:defRPr>
+            </a:pPr>
+            <a:r>
+              <a:t>13 avril  :  4</a:t>
+            </a:r>
+          </a:p>
+        </p:txBody>
+      </p:sp>
+      <p:sp>
+        <p:nvSpPr>
+          <p:cNvPr id="38" name="TextBox 37"/>
+          <p:cNvSpPr txBox="1"/>
+          <p:nvPr/>
+        </p:nvSpPr>
+        <p:spPr>
+          <a:xfrm>
             <a:off x="365760" y="4846320"/>
             <a:ext cx="5486400" cy="274320"/>
           </a:xfrm>
@@ -12416,7 +12566,7 @@
       </p:sp>
       <p:graphicFrame>
         <p:nvGraphicFramePr>
-          <p:cNvPr id="38" name="Table 37"/>
+          <p:cNvPr id="39" name="Table 38"/>
           <p:cNvGraphicFramePr>
             <a:graphicFrameLocks noGrp="1"/>
           </p:cNvGraphicFramePr>
@@ -12545,7 +12695,7 @@
                         </a:defRPr>
                       </a:pPr>
                       <a:r>
-                        <a:t>9</a:t>
+                        <a:t>10</a:t>
                       </a:r>
                     </a:p>
                   </a:txBody>
@@ -12758,7 +12908,7 @@
                         </a:defRPr>
                       </a:pPr>
                       <a:r>
-                        <a:t>6</a:t>
+                        <a:t>8</a:t>
                       </a:r>
                     </a:p>
                   </a:txBody>
@@ -12798,7 +12948,7 @@
       </p:graphicFrame>
       <p:sp>
         <p:nvSpPr>
-          <p:cNvPr id="39" name="Rounded Rectangle 38"/>
+          <p:cNvPr id="40" name="Rounded Rectangle 39"/>
           <p:cNvSpPr/>
           <p:nvPr/>
         </p:nvSpPr>
@@ -12843,7 +12993,7 @@
       </p:sp>
       <p:sp>
         <p:nvSpPr>
-          <p:cNvPr id="40" name="TextBox 39"/>
+          <p:cNvPr id="41" name="TextBox 40"/>
           <p:cNvSpPr txBox="1"/>
           <p:nvPr/>
         </p:nvSpPr>
@@ -12878,7 +13028,7 @@
       </p:sp>
       <p:sp>
         <p:nvSpPr>
-          <p:cNvPr id="41" name="TextBox 40"/>
+          <p:cNvPr id="42" name="TextBox 41"/>
           <p:cNvSpPr txBox="1"/>
           <p:nvPr/>
         </p:nvSpPr>
@@ -13147,7 +13297,7 @@
               </a:defRPr>
             </a:pPr>
             <a:r>
-              <a:t>Évolution de la plateforme en 7 jours</a:t>
+              <a:t>Évolution de la plateforme en 8 jours</a:t>
             </a:r>
           </a:p>
         </p:txBody>
@@ -14829,7 +14979,7 @@
               </a:defRPr>
             </a:pPr>
             <a:r>
-              <a:t>The Pulse — d’une base de données à une véritable plateforme communautaire en 7 jours.</a:t>
+              <a:t>The Pulse — d’une base de données à une véritable plateforme communautaire en 8 jours.</a:t>
             </a:r>
           </a:p>
         </p:txBody>
@@ -15070,7 +15220,7 @@
               </a:defRPr>
             </a:pPr>
             <a:r>
-              <a:t>Synthèse J+7</a:t>
+              <a:t>Synthèse J+8</a:t>
             </a:r>
           </a:p>
         </p:txBody>
@@ -15111,7 +15261,7 @@
                   <a:srgbClr val="475569"/>
                 </a:solidFill>
               </a:rPr>
-              <a:t>1 700 utilisateurs actifs et 2 441 sessions en 7 jours, principalement depuis le Maroc (80%).</a:t>
+              <a:t>1 855 utilisateurs actifs et 2 665 sessions en 8 jours, principalement depuis le Maroc (78%).</a:t>
             </a:r>
           </a:p>
         </p:txBody>
@@ -15193,7 +15343,7 @@
                   <a:srgbClr val="475569"/>
                 </a:solidFill>
               </a:rPr>
-              <a:t>57,7% de taux d’engagement, durée moyenne de session de 1m 34s, 44 inscriptions effectives en 7 jours.</a:t>
+              <a:t>57,7% de taux d’engagement, durée moyenne de session de 1m 34s, 48 inscriptions effectives en 8 jours.</a:t>
             </a:r>
           </a:p>
         </p:txBody>
@@ -15234,7 +15384,7 @@
                   <a:srgbClr val="475569"/>
                 </a:solidFill>
               </a:rPr>
-              <a:t>44 membres inscrits dont 33 entrepreneurs, 5 investisseurs, 3 experts et 3 programmes.</a:t>
+              <a:t>48 membres inscrits dont 35 entrepreneurs, 5 investisseurs, 5 experts et 3 programmes.</a:t>
             </a:r>
           </a:p>
         </p:txBody>
@@ -15386,7 +15536,7 @@
               </a:defRPr>
             </a:pPr>
             <a:r>
-              <a:t>● Activation des 27 comptes en attente de confirmation (61% des inscrits)</a:t>
+              <a:t>● Activation des 26 comptes en attente de confirmation (54% des inscrits)</a:t>
             </a:r>
           </a:p>
         </p:txBody>
@@ -15686,7 +15836,7 @@
                         </a:defRPr>
                       </a:pPr>
                       <a:r>
-                        <a:t>44</a:t>
+                        <a:t>48</a:t>
                       </a:r>
                     </a:p>
                   </a:txBody>
@@ -15732,7 +15882,7 @@
                         </a:defRPr>
                       </a:pPr>
                       <a:r>
-                        <a:t>22%</a:t>
+                        <a:t>24%</a:t>
                       </a:r>
                     </a:p>
                   </a:txBody>
@@ -15968,7 +16118,7 @@
                         </a:defRPr>
                       </a:pPr>
                       <a:r>
-                        <a:t>2 441</a:t>
+                        <a:t>2 665</a:t>
                       </a:r>
                     </a:p>
                   </a:txBody>
@@ -16014,7 +16164,7 @@
                         </a:defRPr>
                       </a:pPr>
                       <a:r>
-                        <a:t>49%</a:t>
+                        <a:t>53%</a:t>
                       </a:r>
                     </a:p>
                   </a:txBody>
@@ -18122,7 +18272,7 @@
               </a:defRPr>
             </a:pPr>
             <a:r>
-              <a:t>The Pulse  |  UM6P  |  thepulse.ma  |  Rapport généré le 12 avril 2026</a:t>
+              <a:t>The Pulse  |  UM6P  |  thepulse.ma  |  Rapport généré le 13 avril 2026</a:t>
             </a:r>
           </a:p>
         </p:txBody>

</xml_diff>